<commit_message>
chore: upgrade PPTX body font size to 14pt and sync updated docs
</commit_message>
<xml_diff>
--- a/智能體駕馭工程_Claude_Code簡報.pptx
+++ b/智能體駕馭工程_Claude_Code簡報.pptx
@@ -3134,7 +3134,7 @@
           <a:p>
             <a:pPr algn="ctr"/>
             <a:r>
-              <a:rPr sz="3600" b="1">
+              <a:rPr xmlns:ns0="http://schemas.openxmlformats.org/wordprocessingml/2006/main" sz="3600" b="1" ns0:eastAsia="Microsoft JhengHei">
                 <a:solidFill>
                   <a:srgbClr val="FFFFFF"/>
                 </a:solidFill>
@@ -3170,7 +3170,7 @@
           <a:p>
             <a:pPr algn="ctr"/>
             <a:r>
-              <a:rPr sz="2000">
+              <a:rPr xmlns:ns1="http://schemas.openxmlformats.org/wordprocessingml/2006/main" sz="2000" ns1:eastAsia="Microsoft JhengHei">
                 <a:solidFill>
                   <a:srgbClr val="94A3B8"/>
                 </a:solidFill>
@@ -3206,7 +3206,7 @@
           <a:p>
             <a:pPr algn="ctr"/>
             <a:r>
-              <a:rPr sz="1200">
+              <a:rPr xmlns:ns2="http://schemas.openxmlformats.org/wordprocessingml/2006/main" sz="1400" ns2:eastAsia="Microsoft JhengHei">
                 <a:solidFill>
                   <a:srgbClr val="64748B"/>
                 </a:solidFill>
@@ -3268,7 +3268,7 @@
           <a:p>
             <a:pPr algn="l"/>
             <a:r>
-              <a:rPr sz="3000" b="1">
+              <a:rPr xmlns:ns0="http://schemas.openxmlformats.org/wordprocessingml/2006/main" sz="3000" b="1" ns0:eastAsia="Microsoft JhengHei">
                 <a:solidFill>
                   <a:srgbClr val="1B2A4A"/>
                 </a:solidFill>
@@ -3304,7 +3304,7 @@
           <a:p>
             <a:pPr algn="l"/>
             <a:r>
-              <a:rPr sz="1400">
+              <a:rPr xmlns:ns1="http://schemas.openxmlformats.org/wordprocessingml/2006/main" sz="1400" ns1:eastAsia="Microsoft JhengHei">
                 <a:solidFill>
                   <a:srgbClr val="0E7C86"/>
                 </a:solidFill>
@@ -3354,7 +3354,7 @@
           </a:fontRef>
         </p:style>
         <p:txBody>
-          <a:bodyPr rtlCol="0" anchor="ctr"/>
+          <a:bodyPr rtlCol="0" anchor="ctr" wrap="square"/>
           <a:lstStyle/>
           <a:p>
             <a:pPr algn="ctr"/>
@@ -3397,7 +3397,7 @@
           </a:fontRef>
         </p:style>
         <p:txBody>
-          <a:bodyPr rtlCol="0" anchor="ctr"/>
+          <a:bodyPr rtlCol="0" anchor="ctr" wrap="square"/>
           <a:lstStyle/>
           <a:p>
             <a:pPr algn="ctr"/>
@@ -3428,7 +3428,7 @@
           <a:p>
             <a:pPr algn="l"/>
             <a:r>
-              <a:rPr sz="1400" b="1">
+              <a:rPr xmlns:ns2="http://schemas.openxmlformats.org/wordprocessingml/2006/main" sz="1400" b="1" ns2:eastAsia="Microsoft JhengHei">
                 <a:solidFill>
                   <a:srgbClr val="1B2A4A"/>
                 </a:solidFill>
@@ -3464,7 +3464,7 @@
           <a:p>
             <a:pPr algn="l"/>
             <a:r>
-              <a:rPr sz="1100">
+              <a:rPr xmlns:ns3="http://schemas.openxmlformats.org/wordprocessingml/2006/main" sz="1400" ns3:eastAsia="Microsoft JhengHei">
                 <a:solidFill>
                   <a:srgbClr val="3A4A63"/>
                 </a:solidFill>
@@ -3514,7 +3514,7 @@
           </a:fontRef>
         </p:style>
         <p:txBody>
-          <a:bodyPr rtlCol="0" anchor="ctr"/>
+          <a:bodyPr rtlCol="0" anchor="ctr" wrap="square"/>
           <a:lstStyle/>
           <a:p>
             <a:pPr algn="ctr"/>
@@ -3557,7 +3557,7 @@
           </a:fontRef>
         </p:style>
         <p:txBody>
-          <a:bodyPr rtlCol="0" anchor="ctr"/>
+          <a:bodyPr rtlCol="0" anchor="ctr" wrap="square"/>
           <a:lstStyle/>
           <a:p>
             <a:pPr algn="ctr"/>
@@ -3588,7 +3588,7 @@
           <a:p>
             <a:pPr algn="l"/>
             <a:r>
-              <a:rPr sz="1400" b="1">
+              <a:rPr xmlns:ns4="http://schemas.openxmlformats.org/wordprocessingml/2006/main" sz="1400" b="1" ns4:eastAsia="Microsoft JhengHei">
                 <a:solidFill>
                   <a:srgbClr val="1B2A4A"/>
                 </a:solidFill>
@@ -3624,7 +3624,7 @@
           <a:p>
             <a:pPr algn="l"/>
             <a:r>
-              <a:rPr sz="1100">
+              <a:rPr xmlns:ns5="http://schemas.openxmlformats.org/wordprocessingml/2006/main" sz="1400" ns5:eastAsia="Microsoft JhengHei">
                 <a:solidFill>
                   <a:srgbClr val="3A4A63"/>
                 </a:solidFill>
@@ -3674,7 +3674,7 @@
           </a:fontRef>
         </p:style>
         <p:txBody>
-          <a:bodyPr rtlCol="0" anchor="ctr"/>
+          <a:bodyPr rtlCol="0" anchor="ctr" wrap="square"/>
           <a:lstStyle/>
           <a:p>
             <a:pPr algn="ctr"/>
@@ -3717,7 +3717,7 @@
           </a:fontRef>
         </p:style>
         <p:txBody>
-          <a:bodyPr rtlCol="0" anchor="ctr"/>
+          <a:bodyPr rtlCol="0" anchor="ctr" wrap="square"/>
           <a:lstStyle/>
           <a:p>
             <a:pPr algn="ctr"/>
@@ -3748,7 +3748,7 @@
           <a:p>
             <a:pPr algn="l"/>
             <a:r>
-              <a:rPr sz="1400" b="1">
+              <a:rPr xmlns:ns6="http://schemas.openxmlformats.org/wordprocessingml/2006/main" sz="1400" b="1" ns6:eastAsia="Microsoft JhengHei">
                 <a:solidFill>
                   <a:srgbClr val="1B2A4A"/>
                 </a:solidFill>
@@ -3784,7 +3784,7 @@
           <a:p>
             <a:pPr algn="l"/>
             <a:r>
-              <a:rPr sz="1100">
+              <a:rPr xmlns:ns7="http://schemas.openxmlformats.org/wordprocessingml/2006/main" sz="1400" ns7:eastAsia="Microsoft JhengHei">
                 <a:solidFill>
                   <a:srgbClr val="3A4A63"/>
                 </a:solidFill>
@@ -3834,7 +3834,7 @@
           </a:fontRef>
         </p:style>
         <p:txBody>
-          <a:bodyPr rtlCol="0" anchor="ctr"/>
+          <a:bodyPr rtlCol="0" anchor="ctr" wrap="square"/>
           <a:lstStyle/>
           <a:p>
             <a:pPr algn="ctr"/>
@@ -3877,7 +3877,7 @@
           </a:fontRef>
         </p:style>
         <p:txBody>
-          <a:bodyPr rtlCol="0" anchor="ctr"/>
+          <a:bodyPr rtlCol="0" anchor="ctr" wrap="square"/>
           <a:lstStyle/>
           <a:p>
             <a:pPr algn="ctr"/>
@@ -3908,7 +3908,7 @@
           <a:p>
             <a:pPr algn="l"/>
             <a:r>
-              <a:rPr sz="1400" b="1">
+              <a:rPr xmlns:ns8="http://schemas.openxmlformats.org/wordprocessingml/2006/main" sz="1400" b="1" ns8:eastAsia="Microsoft JhengHei">
                 <a:solidFill>
                   <a:srgbClr val="1B2A4A"/>
                 </a:solidFill>
@@ -3944,7 +3944,7 @@
           <a:p>
             <a:pPr algn="l"/>
             <a:r>
-              <a:rPr sz="1100">
+              <a:rPr xmlns:ns9="http://schemas.openxmlformats.org/wordprocessingml/2006/main" sz="1400" ns9:eastAsia="Microsoft JhengHei">
                 <a:solidFill>
                   <a:srgbClr val="3A4A63"/>
                 </a:solidFill>
@@ -3996,7 +3996,7 @@
           </a:fontRef>
         </p:style>
         <p:txBody>
-          <a:bodyPr rtlCol="0" anchor="ctr"/>
+          <a:bodyPr rtlCol="0" anchor="ctr" wrap="square"/>
           <a:lstStyle/>
           <a:p>
             <a:pPr algn="ctr"/>
@@ -4027,7 +4027,7 @@
           <a:p>
             <a:pPr algn="ctr"/>
             <a:r>
-              <a:rPr sz="1100" b="1">
+              <a:rPr xmlns:ns10="http://schemas.openxmlformats.org/wordprocessingml/2006/main" sz="1400" b="1" ns10:eastAsia="Microsoft JhengHei">
                 <a:solidFill>
                   <a:srgbClr val="B3372B"/>
                 </a:solidFill>
@@ -4056,22 +4056,101 @@
           <a:noFill/>
         </p:spPr>
         <p:txBody>
-          <a:bodyPr wrap="none">
+          <a:bodyPr wrap="square">
             <a:spAutoFit/>
           </a:bodyPr>
           <a:lstStyle/>
           <a:p>
             <a:pPr algn="r"/>
             <a:r>
+              <a:rPr xmlns:ns11="http://schemas.openxmlformats.org/wordprocessingml/2006/main" sz="1400" ns11:eastAsia="Microsoft JhengHei">
+                <a:solidFill>
+                  <a:srgbClr val="6B7280"/>
+                </a:solidFill>
+                <a:latin typeface="Microsoft JhengHei"/>
+                <a:rFonts ea="Microsoft JhengHei"/>
+              </a:rPr>
+              <a:t>10</a:t>
+            </a:r>
+          </a:p>
+        </p:txBody>
+      </p:sp>
+      <p:sp>
+        <p:nvSpPr>
+          <p:cNvPr id="23" name="TextBox 22"/>
+          <p:cNvSpPr txBox="1"/>
+          <p:nvPr/>
+        </p:nvSpPr>
+        <p:spPr>
+          <a:xfrm>
+            <a:off x="11247120" y="6446520"/>
+            <a:ext cx="731520" cy="274320"/>
+          </a:xfrm>
+          <a:prstGeom prst="rect">
+            <a:avLst/>
+          </a:prstGeom>
+          <a:noFill/>
+        </p:spPr>
+        <p:txBody>
+          <a:bodyPr wrap="square">
+            <a:spAutoFit/>
+          </a:bodyPr>
+          <a:lstStyle/>
+          <a:p>
+            <a:pPr algn="r"/>
+            <a:r>
               <a:rPr sz="900">
                 <a:solidFill>
                   <a:srgbClr val="6B7280"/>
                 </a:solidFill>
                 <a:latin typeface="Microsoft JhengHei"/>
-                <a:rFonts ea="Microsoft JhengHei"/>
+                <a:rFonts a:ea="Microsoft JhengHei"/>
               </a:rPr>
               <a:t>10</a:t>
             </a:r>
+          </a:p>
+        </p:txBody>
+      </p:sp>
+      <p:sp>
+        <p:nvSpPr>
+          <p:cNvPr id="24" name="Rectangle 23"/>
+          <p:cNvSpPr/>
+          <p:nvPr/>
+        </p:nvSpPr>
+        <p:spPr>
+          <a:xfrm>
+            <a:off x="320040" y="1371600"/>
+            <a:ext cx="73152" cy="5029200"/>
+          </a:xfrm>
+          <a:prstGeom prst="rect">
+            <a:avLst/>
+          </a:prstGeom>
+          <a:solidFill>
+            <a:srgbClr val="10B981"/>
+          </a:solidFill>
+          <a:ln>
+            <a:noFill/>
+          </a:ln>
+        </p:spPr>
+        <p:style>
+          <a:lnRef idx="1">
+            <a:schemeClr val="accent1"/>
+          </a:lnRef>
+          <a:fillRef idx="3">
+            <a:schemeClr val="accent1"/>
+          </a:fillRef>
+          <a:effectRef idx="2">
+            <a:schemeClr val="accent1"/>
+          </a:effectRef>
+          <a:fontRef idx="minor">
+            <a:schemeClr val="lt1"/>
+          </a:fontRef>
+        </p:style>
+        <p:txBody>
+          <a:bodyPr rtlCol="0" anchor="ctr" wrap="square"/>
+          <a:lstStyle/>
+          <a:p>
+            <a:pPr algn="ctr"/>
           </a:p>
         </p:txBody>
       </p:sp>
@@ -4125,7 +4204,7 @@
           <a:p>
             <a:pPr algn="l"/>
             <a:r>
-              <a:rPr sz="3000" b="1">
+              <a:rPr xmlns:ns0="http://schemas.openxmlformats.org/wordprocessingml/2006/main" sz="3000" b="1" ns0:eastAsia="Microsoft JhengHei">
                 <a:solidFill>
                   <a:srgbClr val="1B2A4A"/>
                 </a:solidFill>
@@ -4161,7 +4240,7 @@
           <a:p>
             <a:pPr algn="l"/>
             <a:r>
-              <a:rPr sz="1400">
+              <a:rPr xmlns:ns1="http://schemas.openxmlformats.org/wordprocessingml/2006/main" sz="1400" ns1:eastAsia="Microsoft JhengHei">
                 <a:solidFill>
                   <a:srgbClr val="0E7C86"/>
                 </a:solidFill>
@@ -4211,7 +4290,7 @@
           </a:fontRef>
         </p:style>
         <p:txBody>
-          <a:bodyPr rtlCol="0" anchor="ctr"/>
+          <a:bodyPr rtlCol="0" anchor="ctr" wrap="square"/>
           <a:lstStyle/>
           <a:p>
             <a:pPr algn="ctr"/>
@@ -4254,7 +4333,7 @@
           </a:fontRef>
         </p:style>
         <p:txBody>
-          <a:bodyPr rtlCol="0" anchor="ctr"/>
+          <a:bodyPr rtlCol="0" anchor="ctr" wrap="square"/>
           <a:lstStyle/>
           <a:p>
             <a:pPr algn="ctr"/>
@@ -4285,7 +4364,7 @@
           <a:p>
             <a:pPr algn="l"/>
             <a:r>
-              <a:rPr sz="1400" b="1">
+              <a:rPr xmlns:ns2="http://schemas.openxmlformats.org/wordprocessingml/2006/main" sz="1400" b="1" ns2:eastAsia="Microsoft JhengHei">
                 <a:solidFill>
                   <a:srgbClr val="1B2A4A"/>
                 </a:solidFill>
@@ -4321,7 +4400,7 @@
           <a:p>
             <a:pPr algn="l"/>
             <a:r>
-              <a:rPr sz="1100">
+              <a:rPr xmlns:ns3="http://schemas.openxmlformats.org/wordprocessingml/2006/main" sz="1400" ns3:eastAsia="Microsoft JhengHei">
                 <a:solidFill>
                   <a:srgbClr val="3A4A63"/>
                 </a:solidFill>
@@ -4371,7 +4450,7 @@
           </a:fontRef>
         </p:style>
         <p:txBody>
-          <a:bodyPr rtlCol="0" anchor="ctr"/>
+          <a:bodyPr rtlCol="0" anchor="ctr" wrap="square"/>
           <a:lstStyle/>
           <a:p>
             <a:pPr algn="ctr"/>
@@ -4414,7 +4493,7 @@
           </a:fontRef>
         </p:style>
         <p:txBody>
-          <a:bodyPr rtlCol="0" anchor="ctr"/>
+          <a:bodyPr rtlCol="0" anchor="ctr" wrap="square"/>
           <a:lstStyle/>
           <a:p>
             <a:pPr algn="ctr"/>
@@ -4445,7 +4524,7 @@
           <a:p>
             <a:pPr algn="l"/>
             <a:r>
-              <a:rPr sz="1400" b="1">
+              <a:rPr xmlns:ns4="http://schemas.openxmlformats.org/wordprocessingml/2006/main" sz="1400" b="1" ns4:eastAsia="Microsoft JhengHei">
                 <a:solidFill>
                   <a:srgbClr val="1B2A4A"/>
                 </a:solidFill>
@@ -4481,7 +4560,7 @@
           <a:p>
             <a:pPr algn="l"/>
             <a:r>
-              <a:rPr sz="1100">
+              <a:rPr xmlns:ns5="http://schemas.openxmlformats.org/wordprocessingml/2006/main" sz="1400" ns5:eastAsia="Microsoft JhengHei">
                 <a:solidFill>
                   <a:srgbClr val="3A4A63"/>
                 </a:solidFill>
@@ -4531,7 +4610,7 @@
           </a:fontRef>
         </p:style>
         <p:txBody>
-          <a:bodyPr rtlCol="0" anchor="ctr"/>
+          <a:bodyPr rtlCol="0" anchor="ctr" wrap="square"/>
           <a:lstStyle/>
           <a:p>
             <a:pPr algn="ctr"/>
@@ -4574,7 +4653,7 @@
           </a:fontRef>
         </p:style>
         <p:txBody>
-          <a:bodyPr rtlCol="0" anchor="ctr"/>
+          <a:bodyPr rtlCol="0" anchor="ctr" wrap="square"/>
           <a:lstStyle/>
           <a:p>
             <a:pPr algn="ctr"/>
@@ -4605,7 +4684,7 @@
           <a:p>
             <a:pPr algn="l"/>
             <a:r>
-              <a:rPr sz="1400" b="1">
+              <a:rPr xmlns:ns6="http://schemas.openxmlformats.org/wordprocessingml/2006/main" sz="1400" b="1" ns6:eastAsia="Microsoft JhengHei">
                 <a:solidFill>
                   <a:srgbClr val="1B2A4A"/>
                 </a:solidFill>
@@ -4641,7 +4720,7 @@
           <a:p>
             <a:pPr algn="l"/>
             <a:r>
-              <a:rPr sz="1100">
+              <a:rPr xmlns:ns7="http://schemas.openxmlformats.org/wordprocessingml/2006/main" sz="1400" ns7:eastAsia="Microsoft JhengHei">
                 <a:solidFill>
                   <a:srgbClr val="3A4A63"/>
                 </a:solidFill>
@@ -4692,7 +4771,7 @@
           </a:fontRef>
         </p:style>
         <p:txBody>
-          <a:bodyPr rtlCol="0" anchor="ctr"/>
+          <a:bodyPr rtlCol="0" anchor="ctr" wrap="square"/>
           <a:lstStyle/>
           <a:p>
             <a:pPr algn="ctr"/>
@@ -4735,7 +4814,7 @@
           </a:fontRef>
         </p:style>
         <p:txBody>
-          <a:bodyPr rtlCol="0" anchor="ctr"/>
+          <a:bodyPr rtlCol="0" anchor="ctr" wrap="square"/>
           <a:lstStyle/>
           <a:p>
             <a:pPr algn="ctr"/>
@@ -4766,7 +4845,7 @@
           <a:p>
             <a:pPr algn="l"/>
             <a:r>
-              <a:rPr sz="1400" b="1">
+              <a:rPr xmlns:ns8="http://schemas.openxmlformats.org/wordprocessingml/2006/main" sz="1400" b="1" ns8:eastAsia="Microsoft JhengHei">
                 <a:solidFill>
                   <a:srgbClr val="1B2A4A"/>
                 </a:solidFill>
@@ -4802,7 +4881,7 @@
           <a:p>
             <a:pPr algn="l"/>
             <a:r>
-              <a:rPr sz="1100">
+              <a:rPr xmlns:ns9="http://schemas.openxmlformats.org/wordprocessingml/2006/main" sz="1400" ns9:eastAsia="Microsoft JhengHei">
                 <a:solidFill>
                   <a:srgbClr val="3A4A63"/>
                 </a:solidFill>
@@ -4831,22 +4910,101 @@
           <a:noFill/>
         </p:spPr>
         <p:txBody>
-          <a:bodyPr wrap="none">
+          <a:bodyPr wrap="square">
             <a:spAutoFit/>
           </a:bodyPr>
           <a:lstStyle/>
           <a:p>
             <a:pPr algn="r"/>
             <a:r>
+              <a:rPr xmlns:ns10="http://schemas.openxmlformats.org/wordprocessingml/2006/main" sz="1400" ns10:eastAsia="Microsoft JhengHei">
+                <a:solidFill>
+                  <a:srgbClr val="6B7280"/>
+                </a:solidFill>
+                <a:latin typeface="Microsoft JhengHei"/>
+                <a:rFonts ea="Microsoft JhengHei"/>
+              </a:rPr>
+              <a:t>11</a:t>
+            </a:r>
+          </a:p>
+        </p:txBody>
+      </p:sp>
+      <p:sp>
+        <p:nvSpPr>
+          <p:cNvPr id="21" name="TextBox 20"/>
+          <p:cNvSpPr txBox="1"/>
+          <p:nvPr/>
+        </p:nvSpPr>
+        <p:spPr>
+          <a:xfrm>
+            <a:off x="11247120" y="6446520"/>
+            <a:ext cx="731520" cy="274320"/>
+          </a:xfrm>
+          <a:prstGeom prst="rect">
+            <a:avLst/>
+          </a:prstGeom>
+          <a:noFill/>
+        </p:spPr>
+        <p:txBody>
+          <a:bodyPr wrap="square">
+            <a:spAutoFit/>
+          </a:bodyPr>
+          <a:lstStyle/>
+          <a:p>
+            <a:pPr algn="r"/>
+            <a:r>
               <a:rPr sz="900">
                 <a:solidFill>
                   <a:srgbClr val="6B7280"/>
                 </a:solidFill>
                 <a:latin typeface="Microsoft JhengHei"/>
-                <a:rFonts ea="Microsoft JhengHei"/>
+                <a:rFonts a:ea="Microsoft JhengHei"/>
               </a:rPr>
               <a:t>11</a:t>
             </a:r>
+          </a:p>
+        </p:txBody>
+      </p:sp>
+      <p:sp>
+        <p:nvSpPr>
+          <p:cNvPr id="22" name="Rectangle 21"/>
+          <p:cNvSpPr/>
+          <p:nvPr/>
+        </p:nvSpPr>
+        <p:spPr>
+          <a:xfrm>
+            <a:off x="320040" y="1371600"/>
+            <a:ext cx="73152" cy="5029200"/>
+          </a:xfrm>
+          <a:prstGeom prst="rect">
+            <a:avLst/>
+          </a:prstGeom>
+          <a:solidFill>
+            <a:srgbClr val="0E7C86"/>
+          </a:solidFill>
+          <a:ln>
+            <a:noFill/>
+          </a:ln>
+        </p:spPr>
+        <p:style>
+          <a:lnRef idx="1">
+            <a:schemeClr val="accent1"/>
+          </a:lnRef>
+          <a:fillRef idx="3">
+            <a:schemeClr val="accent1"/>
+          </a:fillRef>
+          <a:effectRef idx="2">
+            <a:schemeClr val="accent1"/>
+          </a:effectRef>
+          <a:fontRef idx="minor">
+            <a:schemeClr val="lt1"/>
+          </a:fontRef>
+        </p:style>
+        <p:txBody>
+          <a:bodyPr rtlCol="0" anchor="ctr" wrap="square"/>
+          <a:lstStyle/>
+          <a:p>
+            <a:pPr algn="ctr"/>
           </a:p>
         </p:txBody>
       </p:sp>
@@ -4900,7 +5058,7 @@
           <a:p>
             <a:pPr algn="l"/>
             <a:r>
-              <a:rPr sz="3000" b="1">
+              <a:rPr xmlns:ns0="http://schemas.openxmlformats.org/wordprocessingml/2006/main" sz="3000" b="1" ns0:eastAsia="Microsoft JhengHei">
                 <a:solidFill>
                   <a:srgbClr val="1B2A4A"/>
                 </a:solidFill>
@@ -4936,7 +5094,7 @@
           <a:p>
             <a:pPr algn="l"/>
             <a:r>
-              <a:rPr sz="1400">
+              <a:rPr xmlns:ns1="http://schemas.openxmlformats.org/wordprocessingml/2006/main" sz="1400" ns1:eastAsia="Microsoft JhengHei">
                 <a:solidFill>
                   <a:srgbClr val="0E7C86"/>
                 </a:solidFill>
@@ -4972,7 +5130,7 @@
           <a:p>
             <a:pPr algn="l"/>
             <a:r>
-              <a:rPr sz="1200" b="1">
+              <a:rPr xmlns:ns2="http://schemas.openxmlformats.org/wordprocessingml/2006/main" sz="1400" b="1" ns2:eastAsia="Microsoft JhengHei">
                 <a:solidFill>
                   <a:srgbClr val="1B2A4A"/>
                 </a:solidFill>
@@ -5022,7 +5180,7 @@
           </a:fontRef>
         </p:style>
         <p:txBody>
-          <a:bodyPr rtlCol="0" anchor="ctr"/>
+          <a:bodyPr rtlCol="0" anchor="ctr" wrap="square"/>
           <a:lstStyle/>
           <a:p>
             <a:pPr algn="ctr"/>
@@ -5065,7 +5223,7 @@
           </a:fontRef>
         </p:style>
         <p:txBody>
-          <a:bodyPr rtlCol="0" anchor="ctr"/>
+          <a:bodyPr rtlCol="0" anchor="ctr" wrap="square"/>
           <a:lstStyle/>
           <a:p>
             <a:pPr algn="ctr"/>
@@ -5096,7 +5254,7 @@
           <a:p>
             <a:pPr algn="l"/>
             <a:r>
-              <a:rPr sz="1200" b="1">
+              <a:rPr xmlns:ns3="http://schemas.openxmlformats.org/wordprocessingml/2006/main" sz="1400" b="1" ns3:eastAsia="Microsoft JhengHei">
                 <a:solidFill>
                   <a:srgbClr val="1B2A4A"/>
                 </a:solidFill>
@@ -5132,7 +5290,7 @@
           <a:p>
             <a:pPr algn="l"/>
             <a:r>
-              <a:rPr sz="1000">
+              <a:rPr xmlns:ns4="http://schemas.openxmlformats.org/wordprocessingml/2006/main" sz="1400" ns4:eastAsia="Microsoft JhengHei">
                 <a:solidFill>
                   <a:srgbClr val="3A4A63"/>
                 </a:solidFill>
@@ -5182,7 +5340,7 @@
           </a:fontRef>
         </p:style>
         <p:txBody>
-          <a:bodyPr rtlCol="0" anchor="ctr"/>
+          <a:bodyPr rtlCol="0" anchor="ctr" wrap="square"/>
           <a:lstStyle/>
           <a:p>
             <a:pPr algn="ctr"/>
@@ -5225,7 +5383,7 @@
           </a:fontRef>
         </p:style>
         <p:txBody>
-          <a:bodyPr rtlCol="0" anchor="ctr"/>
+          <a:bodyPr rtlCol="0" anchor="ctr" wrap="square"/>
           <a:lstStyle/>
           <a:p>
             <a:pPr algn="ctr"/>
@@ -5256,7 +5414,7 @@
           <a:p>
             <a:pPr algn="l"/>
             <a:r>
-              <a:rPr sz="1200" b="1">
+              <a:rPr xmlns:ns5="http://schemas.openxmlformats.org/wordprocessingml/2006/main" sz="1400" b="1" ns5:eastAsia="Microsoft JhengHei">
                 <a:solidFill>
                   <a:srgbClr val="1B2A4A"/>
                 </a:solidFill>
@@ -5292,7 +5450,7 @@
           <a:p>
             <a:pPr algn="l"/>
             <a:r>
-              <a:rPr sz="1000">
+              <a:rPr xmlns:ns6="http://schemas.openxmlformats.org/wordprocessingml/2006/main" sz="1400" ns6:eastAsia="Microsoft JhengHei">
                 <a:solidFill>
                   <a:srgbClr val="3A4A63"/>
                 </a:solidFill>
@@ -5342,7 +5500,7 @@
           </a:fontRef>
         </p:style>
         <p:txBody>
-          <a:bodyPr rtlCol="0" anchor="ctr"/>
+          <a:bodyPr rtlCol="0" anchor="ctr" wrap="square"/>
           <a:lstStyle/>
           <a:p>
             <a:pPr algn="ctr"/>
@@ -5385,7 +5543,7 @@
           </a:fontRef>
         </p:style>
         <p:txBody>
-          <a:bodyPr rtlCol="0" anchor="ctr"/>
+          <a:bodyPr rtlCol="0" anchor="ctr" wrap="square"/>
           <a:lstStyle/>
           <a:p>
             <a:pPr algn="ctr"/>
@@ -5416,7 +5574,7 @@
           <a:p>
             <a:pPr algn="l"/>
             <a:r>
-              <a:rPr sz="1200" b="1">
+              <a:rPr xmlns:ns7="http://schemas.openxmlformats.org/wordprocessingml/2006/main" sz="1400" b="1" ns7:eastAsia="Microsoft JhengHei">
                 <a:solidFill>
                   <a:srgbClr val="1B2A4A"/>
                 </a:solidFill>
@@ -5452,7 +5610,7 @@
           <a:p>
             <a:pPr algn="l"/>
             <a:r>
-              <a:rPr sz="1000">
+              <a:rPr xmlns:ns8="http://schemas.openxmlformats.org/wordprocessingml/2006/main" sz="1400" ns8:eastAsia="Microsoft JhengHei">
                 <a:solidFill>
                   <a:srgbClr val="3A4A63"/>
                 </a:solidFill>
@@ -5502,7 +5660,7 @@
           </a:fontRef>
         </p:style>
         <p:txBody>
-          <a:bodyPr rtlCol="0" anchor="ctr"/>
+          <a:bodyPr rtlCol="0" anchor="ctr" wrap="square"/>
           <a:lstStyle/>
           <a:p>
             <a:pPr algn="ctr"/>
@@ -5545,7 +5703,7 @@
           </a:fontRef>
         </p:style>
         <p:txBody>
-          <a:bodyPr rtlCol="0" anchor="ctr"/>
+          <a:bodyPr rtlCol="0" anchor="ctr" wrap="square"/>
           <a:lstStyle/>
           <a:p>
             <a:pPr algn="ctr"/>
@@ -5576,7 +5734,7 @@
           <a:p>
             <a:pPr algn="l"/>
             <a:r>
-              <a:rPr sz="1200" b="1">
+              <a:rPr xmlns:ns9="http://schemas.openxmlformats.org/wordprocessingml/2006/main" sz="1400" b="1" ns9:eastAsia="Microsoft JhengHei">
                 <a:solidFill>
                   <a:srgbClr val="1B2A4A"/>
                 </a:solidFill>
@@ -5612,7 +5770,7 @@
           <a:p>
             <a:pPr algn="l"/>
             <a:r>
-              <a:rPr sz="1000">
+              <a:rPr xmlns:ns10="http://schemas.openxmlformats.org/wordprocessingml/2006/main" sz="1400" ns10:eastAsia="Microsoft JhengHei">
                 <a:solidFill>
                   <a:srgbClr val="3A4A63"/>
                 </a:solidFill>
@@ -5662,7 +5820,7 @@
           </a:fontRef>
         </p:style>
         <p:txBody>
-          <a:bodyPr rtlCol="0" anchor="ctr"/>
+          <a:bodyPr rtlCol="0" anchor="ctr" wrap="square"/>
           <a:lstStyle/>
           <a:p>
             <a:pPr algn="ctr"/>
@@ -5705,7 +5863,7 @@
           </a:fontRef>
         </p:style>
         <p:txBody>
-          <a:bodyPr rtlCol="0" anchor="ctr"/>
+          <a:bodyPr rtlCol="0" anchor="ctr" wrap="square"/>
           <a:lstStyle/>
           <a:p>
             <a:pPr algn="ctr"/>
@@ -5736,7 +5894,7 @@
           <a:p>
             <a:pPr algn="l"/>
             <a:r>
-              <a:rPr sz="1400" b="1">
+              <a:rPr xmlns:ns11="http://schemas.openxmlformats.org/wordprocessingml/2006/main" sz="1400" b="1" ns11:eastAsia="Microsoft JhengHei">
                 <a:solidFill>
                   <a:srgbClr val="1B2A4A"/>
                 </a:solidFill>
@@ -5772,7 +5930,7 @@
           <a:p>
             <a:pPr algn="l"/>
             <a:r>
-              <a:rPr sz="1100">
+              <a:rPr xmlns:ns12="http://schemas.openxmlformats.org/wordprocessingml/2006/main" sz="1400" ns12:eastAsia="Microsoft JhengHei">
                 <a:solidFill>
                   <a:srgbClr val="3A4A63"/>
                 </a:solidFill>
@@ -5802,22 +5960,101 @@
           <a:noFill/>
         </p:spPr>
         <p:txBody>
-          <a:bodyPr wrap="none">
+          <a:bodyPr wrap="square">
             <a:spAutoFit/>
           </a:bodyPr>
           <a:lstStyle/>
           <a:p>
             <a:pPr algn="r"/>
             <a:r>
+              <a:rPr xmlns:ns13="http://schemas.openxmlformats.org/wordprocessingml/2006/main" sz="1400" ns13:eastAsia="Microsoft JhengHei">
+                <a:solidFill>
+                  <a:srgbClr val="6B7280"/>
+                </a:solidFill>
+                <a:latin typeface="Microsoft JhengHei"/>
+                <a:rFonts ea="Microsoft JhengHei"/>
+              </a:rPr>
+              <a:t>12</a:t>
+            </a:r>
+          </a:p>
+        </p:txBody>
+      </p:sp>
+      <p:sp>
+        <p:nvSpPr>
+          <p:cNvPr id="26" name="TextBox 25"/>
+          <p:cNvSpPr txBox="1"/>
+          <p:nvPr/>
+        </p:nvSpPr>
+        <p:spPr>
+          <a:xfrm>
+            <a:off x="11247120" y="6446520"/>
+            <a:ext cx="731520" cy="274320"/>
+          </a:xfrm>
+          <a:prstGeom prst="rect">
+            <a:avLst/>
+          </a:prstGeom>
+          <a:noFill/>
+        </p:spPr>
+        <p:txBody>
+          <a:bodyPr wrap="square">
+            <a:spAutoFit/>
+          </a:bodyPr>
+          <a:lstStyle/>
+          <a:p>
+            <a:pPr algn="r"/>
+            <a:r>
               <a:rPr sz="900">
                 <a:solidFill>
                   <a:srgbClr val="6B7280"/>
                 </a:solidFill>
                 <a:latin typeface="Microsoft JhengHei"/>
-                <a:rFonts ea="Microsoft JhengHei"/>
+                <a:rFonts a:ea="Microsoft JhengHei"/>
               </a:rPr>
               <a:t>12</a:t>
             </a:r>
+          </a:p>
+        </p:txBody>
+      </p:sp>
+      <p:sp>
+        <p:nvSpPr>
+          <p:cNvPr id="27" name="Rectangle 26"/>
+          <p:cNvSpPr/>
+          <p:nvPr/>
+        </p:nvSpPr>
+        <p:spPr>
+          <a:xfrm>
+            <a:off x="320040" y="1371600"/>
+            <a:ext cx="73152" cy="5029200"/>
+          </a:xfrm>
+          <a:prstGeom prst="rect">
+            <a:avLst/>
+          </a:prstGeom>
+          <a:solidFill>
+            <a:srgbClr val="8B5CF6"/>
+          </a:solidFill>
+          <a:ln>
+            <a:noFill/>
+          </a:ln>
+        </p:spPr>
+        <p:style>
+          <a:lnRef idx="1">
+            <a:schemeClr val="accent1"/>
+          </a:lnRef>
+          <a:fillRef idx="3">
+            <a:schemeClr val="accent1"/>
+          </a:fillRef>
+          <a:effectRef idx="2">
+            <a:schemeClr val="accent1"/>
+          </a:effectRef>
+          <a:fontRef idx="minor">
+            <a:schemeClr val="lt1"/>
+          </a:fontRef>
+        </p:style>
+        <p:txBody>
+          <a:bodyPr rtlCol="0" anchor="ctr" wrap="square"/>
+          <a:lstStyle/>
+          <a:p>
+            <a:pPr algn="ctr"/>
           </a:p>
         </p:txBody>
       </p:sp>
@@ -5871,7 +6108,7 @@
           <a:p>
             <a:pPr algn="l"/>
             <a:r>
-              <a:rPr sz="3000" b="1">
+              <a:rPr xmlns:ns0="http://schemas.openxmlformats.org/wordprocessingml/2006/main" sz="3000" b="1" ns0:eastAsia="Microsoft JhengHei">
                 <a:solidFill>
                   <a:srgbClr val="1B2A4A"/>
                 </a:solidFill>
@@ -5921,7 +6158,7 @@
           </a:fontRef>
         </p:style>
         <p:txBody>
-          <a:bodyPr rtlCol="0" anchor="ctr"/>
+          <a:bodyPr rtlCol="0" anchor="ctr" wrap="square"/>
           <a:lstStyle/>
           <a:p>
             <a:pPr algn="ctr"/>
@@ -5964,7 +6201,7 @@
           </a:fontRef>
         </p:style>
         <p:txBody>
-          <a:bodyPr rtlCol="0" anchor="ctr"/>
+          <a:bodyPr rtlCol="0" anchor="ctr" wrap="square"/>
           <a:lstStyle/>
           <a:p>
             <a:pPr algn="ctr"/>
@@ -5995,7 +6232,7 @@
           <a:p>
             <a:pPr algn="l"/>
             <a:r>
-              <a:rPr sz="1500" b="1">
+              <a:rPr xmlns:ns1="http://schemas.openxmlformats.org/wordprocessingml/2006/main" sz="1500" b="1" ns1:eastAsia="Microsoft JhengHei">
                 <a:solidFill>
                   <a:srgbClr val="1B2A4A"/>
                 </a:solidFill>
@@ -6031,7 +6268,7 @@
           <a:p>
             <a:pPr algn="l"/>
             <a:r>
-              <a:rPr sz="1100">
+              <a:rPr xmlns:ns2="http://schemas.openxmlformats.org/wordprocessingml/2006/main" sz="1400" ns2:eastAsia="Microsoft JhengHei">
                 <a:solidFill>
                   <a:srgbClr val="3A4A63"/>
                 </a:solidFill>
@@ -6081,7 +6318,7 @@
           </a:fontRef>
         </p:style>
         <p:txBody>
-          <a:bodyPr rtlCol="0" anchor="ctr"/>
+          <a:bodyPr rtlCol="0" anchor="ctr" wrap="square"/>
           <a:lstStyle/>
           <a:p>
             <a:pPr algn="ctr"/>
@@ -6124,7 +6361,7 @@
           </a:fontRef>
         </p:style>
         <p:txBody>
-          <a:bodyPr rtlCol="0" anchor="ctr"/>
+          <a:bodyPr rtlCol="0" anchor="ctr" wrap="square"/>
           <a:lstStyle/>
           <a:p>
             <a:pPr algn="ctr"/>
@@ -6155,7 +6392,7 @@
           <a:p>
             <a:pPr algn="l"/>
             <a:r>
-              <a:rPr sz="1500" b="1">
+              <a:rPr xmlns:ns3="http://schemas.openxmlformats.org/wordprocessingml/2006/main" sz="1500" b="1" ns3:eastAsia="Microsoft JhengHei">
                 <a:solidFill>
                   <a:srgbClr val="1B2A4A"/>
                 </a:solidFill>
@@ -6191,7 +6428,7 @@
           <a:p>
             <a:pPr algn="l"/>
             <a:r>
-              <a:rPr sz="1100">
+              <a:rPr xmlns:ns4="http://schemas.openxmlformats.org/wordprocessingml/2006/main" sz="1400" ns4:eastAsia="Microsoft JhengHei">
                 <a:solidFill>
                   <a:srgbClr val="3A4A63"/>
                 </a:solidFill>
@@ -6241,7 +6478,7 @@
           </a:fontRef>
         </p:style>
         <p:txBody>
-          <a:bodyPr rtlCol="0" anchor="ctr"/>
+          <a:bodyPr rtlCol="0" anchor="ctr" wrap="square"/>
           <a:lstStyle/>
           <a:p>
             <a:pPr algn="ctr"/>
@@ -6284,7 +6521,7 @@
           </a:fontRef>
         </p:style>
         <p:txBody>
-          <a:bodyPr rtlCol="0" anchor="ctr"/>
+          <a:bodyPr rtlCol="0" anchor="ctr" wrap="square"/>
           <a:lstStyle/>
           <a:p>
             <a:pPr algn="ctr"/>
@@ -6315,7 +6552,7 @@
           <a:p>
             <a:pPr algn="l"/>
             <a:r>
-              <a:rPr sz="1500" b="1">
+              <a:rPr xmlns:ns5="http://schemas.openxmlformats.org/wordprocessingml/2006/main" sz="1500" b="1" ns5:eastAsia="Microsoft JhengHei">
                 <a:solidFill>
                   <a:srgbClr val="1B2A4A"/>
                 </a:solidFill>
@@ -6351,7 +6588,7 @@
           <a:p>
             <a:pPr algn="l"/>
             <a:r>
-              <a:rPr sz="1100">
+              <a:rPr xmlns:ns6="http://schemas.openxmlformats.org/wordprocessingml/2006/main" sz="1400" ns6:eastAsia="Microsoft JhengHei">
                 <a:solidFill>
                   <a:srgbClr val="3A4A63"/>
                 </a:solidFill>
@@ -6380,22 +6617,101 @@
           <a:noFill/>
         </p:spPr>
         <p:txBody>
-          <a:bodyPr wrap="none">
+          <a:bodyPr wrap="square">
             <a:spAutoFit/>
           </a:bodyPr>
           <a:lstStyle/>
           <a:p>
             <a:pPr algn="r"/>
             <a:r>
+              <a:rPr xmlns:ns7="http://schemas.openxmlformats.org/wordprocessingml/2006/main" sz="1400" ns7:eastAsia="Microsoft JhengHei">
+                <a:solidFill>
+                  <a:srgbClr val="6B7280"/>
+                </a:solidFill>
+                <a:latin typeface="Microsoft JhengHei"/>
+                <a:rFonts ea="Microsoft JhengHei"/>
+              </a:rPr>
+              <a:t>13</a:t>
+            </a:r>
+          </a:p>
+        </p:txBody>
+      </p:sp>
+      <p:sp>
+        <p:nvSpPr>
+          <p:cNvPr id="16" name="TextBox 15"/>
+          <p:cNvSpPr txBox="1"/>
+          <p:nvPr/>
+        </p:nvSpPr>
+        <p:spPr>
+          <a:xfrm>
+            <a:off x="11247120" y="6446520"/>
+            <a:ext cx="731520" cy="274320"/>
+          </a:xfrm>
+          <a:prstGeom prst="rect">
+            <a:avLst/>
+          </a:prstGeom>
+          <a:noFill/>
+        </p:spPr>
+        <p:txBody>
+          <a:bodyPr wrap="square">
+            <a:spAutoFit/>
+          </a:bodyPr>
+          <a:lstStyle/>
+          <a:p>
+            <a:pPr algn="r"/>
+            <a:r>
               <a:rPr sz="900">
                 <a:solidFill>
                   <a:srgbClr val="6B7280"/>
                 </a:solidFill>
                 <a:latin typeface="Microsoft JhengHei"/>
-                <a:rFonts ea="Microsoft JhengHei"/>
+                <a:rFonts a:ea="Microsoft JhengHei"/>
               </a:rPr>
               <a:t>13</a:t>
             </a:r>
+          </a:p>
+        </p:txBody>
+      </p:sp>
+      <p:sp>
+        <p:nvSpPr>
+          <p:cNvPr id="17" name="Rectangle 16"/>
+          <p:cNvSpPr/>
+          <p:nvPr/>
+        </p:nvSpPr>
+        <p:spPr>
+          <a:xfrm>
+            <a:off x="320040" y="1371600"/>
+            <a:ext cx="73152" cy="5029200"/>
+          </a:xfrm>
+          <a:prstGeom prst="rect">
+            <a:avLst/>
+          </a:prstGeom>
+          <a:solidFill>
+            <a:srgbClr val="1B2A4A"/>
+          </a:solidFill>
+          <a:ln>
+            <a:noFill/>
+          </a:ln>
+        </p:spPr>
+        <p:style>
+          <a:lnRef idx="1">
+            <a:schemeClr val="accent1"/>
+          </a:lnRef>
+          <a:fillRef idx="3">
+            <a:schemeClr val="accent1"/>
+          </a:fillRef>
+          <a:effectRef idx="2">
+            <a:schemeClr val="accent1"/>
+          </a:effectRef>
+          <a:fontRef idx="minor">
+            <a:schemeClr val="lt1"/>
+          </a:fontRef>
+        </p:style>
+        <p:txBody>
+          <a:bodyPr rtlCol="0" anchor="ctr" wrap="square"/>
+          <a:lstStyle/>
+          <a:p>
+            <a:pPr algn="ctr"/>
           </a:p>
         </p:txBody>
       </p:sp>
@@ -6449,7 +6765,7 @@
           <a:p>
             <a:pPr algn="l"/>
             <a:r>
-              <a:rPr sz="3000" b="1">
+              <a:rPr xmlns:ns0="http://schemas.openxmlformats.org/wordprocessingml/2006/main" sz="3000" b="1" ns0:eastAsia="Microsoft JhengHei">
                 <a:solidFill>
                   <a:srgbClr val="FFFFFF"/>
                 </a:solidFill>
@@ -6499,7 +6815,7 @@
           </a:fontRef>
         </p:style>
         <p:txBody>
-          <a:bodyPr rtlCol="0" anchor="ctr"/>
+          <a:bodyPr rtlCol="0" anchor="ctr" wrap="square"/>
           <a:lstStyle/>
           <a:p>
             <a:pPr algn="ctr"/>
@@ -6530,7 +6846,7 @@
           <a:p>
             <a:pPr algn="l"/>
             <a:r>
-              <a:rPr sz="1400" b="1">
+              <a:rPr xmlns:ns1="http://schemas.openxmlformats.org/wordprocessingml/2006/main" sz="1400" b="1" ns1:eastAsia="Microsoft JhengHei">
                 <a:solidFill>
                   <a:srgbClr val="FFFFFF"/>
                 </a:solidFill>
@@ -6580,7 +6896,7 @@
           </a:fontRef>
         </p:style>
         <p:txBody>
-          <a:bodyPr rtlCol="0" anchor="ctr"/>
+          <a:bodyPr rtlCol="0" anchor="ctr" wrap="square"/>
           <a:lstStyle/>
           <a:p>
             <a:pPr algn="ctr"/>
@@ -6611,7 +6927,7 @@
           <a:p>
             <a:pPr algn="l"/>
             <a:r>
-              <a:rPr sz="1400" b="1">
+              <a:rPr xmlns:ns2="http://schemas.openxmlformats.org/wordprocessingml/2006/main" sz="1400" b="1" ns2:eastAsia="Microsoft JhengHei">
                 <a:solidFill>
                   <a:srgbClr val="FFFFFF"/>
                 </a:solidFill>
@@ -6661,7 +6977,7 @@
           </a:fontRef>
         </p:style>
         <p:txBody>
-          <a:bodyPr rtlCol="0" anchor="ctr"/>
+          <a:bodyPr rtlCol="0" anchor="ctr" wrap="square"/>
           <a:lstStyle/>
           <a:p>
             <a:pPr algn="ctr"/>
@@ -6692,7 +7008,7 @@
           <a:p>
             <a:pPr algn="l"/>
             <a:r>
-              <a:rPr sz="1400" b="1">
+              <a:rPr xmlns:ns3="http://schemas.openxmlformats.org/wordprocessingml/2006/main" sz="1400" b="1" ns3:eastAsia="Microsoft JhengHei">
                 <a:solidFill>
                   <a:srgbClr val="FFFFFF"/>
                 </a:solidFill>
@@ -6728,7 +7044,7 @@
           <a:p>
             <a:pPr algn="ctr"/>
             <a:r>
-              <a:rPr sz="1800" b="1">
+              <a:rPr xmlns:ns4="http://schemas.openxmlformats.org/wordprocessingml/2006/main" sz="1800" b="1" ns4:eastAsia="Microsoft JhengHei">
                 <a:solidFill>
                   <a:srgbClr val="94A3B8"/>
                 </a:solidFill>
@@ -6757,19 +7073,55 @@
           <a:noFill/>
         </p:spPr>
         <p:txBody>
-          <a:bodyPr wrap="none">
+          <a:bodyPr wrap="square">
             <a:spAutoFit/>
           </a:bodyPr>
           <a:lstStyle/>
           <a:p>
             <a:pPr algn="r"/>
             <a:r>
+              <a:rPr xmlns:ns5="http://schemas.openxmlformats.org/wordprocessingml/2006/main" sz="1400" ns5:eastAsia="Microsoft JhengHei">
+                <a:solidFill>
+                  <a:srgbClr val="6B7280"/>
+                </a:solidFill>
+                <a:latin typeface="Microsoft JhengHei"/>
+                <a:rFonts ea="Microsoft JhengHei"/>
+              </a:rPr>
+              <a:t>14</a:t>
+            </a:r>
+          </a:p>
+        </p:txBody>
+      </p:sp>
+      <p:sp>
+        <p:nvSpPr>
+          <p:cNvPr id="11" name="TextBox 10"/>
+          <p:cNvSpPr txBox="1"/>
+          <p:nvPr/>
+        </p:nvSpPr>
+        <p:spPr>
+          <a:xfrm>
+            <a:off x="11247120" y="6446520"/>
+            <a:ext cx="731520" cy="274320"/>
+          </a:xfrm>
+          <a:prstGeom prst="rect">
+            <a:avLst/>
+          </a:prstGeom>
+          <a:noFill/>
+        </p:spPr>
+        <p:txBody>
+          <a:bodyPr wrap="square">
+            <a:spAutoFit/>
+          </a:bodyPr>
+          <a:lstStyle/>
+          <a:p>
+            <a:pPr algn="r"/>
+            <a:r>
               <a:rPr sz="900">
                 <a:solidFill>
                   <a:srgbClr val="6B7280"/>
                 </a:solidFill>
                 <a:latin typeface="Microsoft JhengHei"/>
-                <a:rFonts ea="Microsoft JhengHei"/>
+                <a:rFonts a:ea="Microsoft JhengHei"/>
               </a:rPr>
               <a:t>14</a:t>
             </a:r>
@@ -6826,7 +7178,7 @@
           <a:p>
             <a:pPr algn="l"/>
             <a:r>
-              <a:rPr sz="3000" b="1">
+              <a:rPr xmlns:ns0="http://schemas.openxmlformats.org/wordprocessingml/2006/main" sz="3000" b="1" ns0:eastAsia="Microsoft JhengHei">
                 <a:solidFill>
                   <a:srgbClr val="1B2A4A"/>
                 </a:solidFill>
@@ -6876,7 +7228,7 @@
           </a:fontRef>
         </p:style>
         <p:txBody>
-          <a:bodyPr rtlCol="0" anchor="ctr"/>
+          <a:bodyPr rtlCol="0" anchor="ctr" wrap="square"/>
           <a:lstStyle/>
           <a:p>
             <a:pPr algn="ctr"/>
@@ -6919,7 +7271,7 @@
           </a:fontRef>
         </p:style>
         <p:txBody>
-          <a:bodyPr rtlCol="0" anchor="ctr"/>
+          <a:bodyPr rtlCol="0" anchor="ctr" wrap="square"/>
           <a:lstStyle/>
           <a:p>
             <a:pPr algn="ctr"/>
@@ -6950,7 +7302,7 @@
           <a:p>
             <a:pPr algn="l"/>
             <a:r>
-              <a:rPr sz="1200">
+              <a:rPr xmlns:ns1="http://schemas.openxmlformats.org/wordprocessingml/2006/main" sz="1400" ns1:eastAsia="Microsoft JhengHei">
                 <a:solidFill>
                   <a:srgbClr val="3A4A63"/>
                 </a:solidFill>
@@ -6983,19 +7335,55 @@
           <a:noFill/>
         </p:spPr>
         <p:txBody>
-          <a:bodyPr wrap="none">
+          <a:bodyPr wrap="square">
             <a:spAutoFit/>
           </a:bodyPr>
           <a:lstStyle/>
           <a:p>
             <a:pPr algn="r"/>
             <a:r>
+              <a:rPr xmlns:ns2="http://schemas.openxmlformats.org/wordprocessingml/2006/main" sz="1400" ns2:eastAsia="Microsoft JhengHei">
+                <a:solidFill>
+                  <a:srgbClr val="6B7280"/>
+                </a:solidFill>
+                <a:latin typeface="Microsoft JhengHei"/>
+                <a:rFonts ea="Microsoft JhengHei"/>
+              </a:rPr>
+              <a:t>15</a:t>
+            </a:r>
+          </a:p>
+        </p:txBody>
+      </p:sp>
+      <p:sp>
+        <p:nvSpPr>
+          <p:cNvPr id="7" name="TextBox 6"/>
+          <p:cNvSpPr txBox="1"/>
+          <p:nvPr/>
+        </p:nvSpPr>
+        <p:spPr>
+          <a:xfrm>
+            <a:off x="11247120" y="6446520"/>
+            <a:ext cx="731520" cy="274320"/>
+          </a:xfrm>
+          <a:prstGeom prst="rect">
+            <a:avLst/>
+          </a:prstGeom>
+          <a:noFill/>
+        </p:spPr>
+        <p:txBody>
+          <a:bodyPr wrap="square">
+            <a:spAutoFit/>
+          </a:bodyPr>
+          <a:lstStyle/>
+          <a:p>
+            <a:pPr algn="r"/>
+            <a:r>
               <a:rPr sz="900">
                 <a:solidFill>
                   <a:srgbClr val="6B7280"/>
                 </a:solidFill>
                 <a:latin typeface="Microsoft JhengHei"/>
-                <a:rFonts ea="Microsoft JhengHei"/>
+                <a:rFonts a:ea="Microsoft JhengHei"/>
               </a:rPr>
               <a:t>15</a:t>
             </a:r>
@@ -7052,7 +7440,7 @@
           <a:p>
             <a:pPr algn="l"/>
             <a:r>
-              <a:rPr sz="3000" b="1">
+              <a:rPr xmlns:ns0="http://schemas.openxmlformats.org/wordprocessingml/2006/main" sz="3000" b="1" ns0:eastAsia="Microsoft JhengHei">
                 <a:solidFill>
                   <a:srgbClr val="1B2A4A"/>
                 </a:solidFill>
@@ -7088,7 +7476,7 @@
           <a:p>
             <a:pPr algn="l"/>
             <a:r>
-              <a:rPr sz="1400">
+              <a:rPr xmlns:ns1="http://schemas.openxmlformats.org/wordprocessingml/2006/main" sz="1400" ns1:eastAsia="Microsoft JhengHei">
                 <a:solidFill>
                   <a:srgbClr val="0E7C86"/>
                 </a:solidFill>
@@ -7138,7 +7526,7 @@
           </a:fontRef>
         </p:style>
         <p:txBody>
-          <a:bodyPr rtlCol="0" anchor="ctr"/>
+          <a:bodyPr rtlCol="0" anchor="ctr" wrap="square"/>
           <a:lstStyle/>
           <a:p>
             <a:pPr algn="ctr"/>
@@ -7181,7 +7569,7 @@
           </a:fontRef>
         </p:style>
         <p:txBody>
-          <a:bodyPr rtlCol="0" anchor="ctr"/>
+          <a:bodyPr rtlCol="0" anchor="ctr" wrap="square"/>
           <a:lstStyle/>
           <a:p>
             <a:pPr algn="ctr"/>
@@ -7212,7 +7600,7 @@
           <a:p>
             <a:pPr algn="l"/>
             <a:r>
-              <a:rPr sz="1400" b="1">
+              <a:rPr xmlns:ns2="http://schemas.openxmlformats.org/wordprocessingml/2006/main" sz="1400" b="1" ns2:eastAsia="Microsoft JhengHei">
                 <a:solidFill>
                   <a:srgbClr val="1B2A4A"/>
                 </a:solidFill>
@@ -7262,7 +7650,7 @@
           </a:fontRef>
         </p:style>
         <p:txBody>
-          <a:bodyPr rtlCol="0" anchor="ctr"/>
+          <a:bodyPr rtlCol="0" anchor="ctr" wrap="square"/>
           <a:lstStyle/>
           <a:p>
             <a:pPr algn="ctr"/>
@@ -7305,7 +7693,7 @@
           </a:fontRef>
         </p:style>
         <p:txBody>
-          <a:bodyPr rtlCol="0" anchor="ctr"/>
+          <a:bodyPr rtlCol="0" anchor="ctr" wrap="square"/>
           <a:lstStyle/>
           <a:p>
             <a:pPr algn="ctr"/>
@@ -7336,7 +7724,7 @@
           <a:p>
             <a:pPr algn="l"/>
             <a:r>
-              <a:rPr sz="1400" b="1">
+              <a:rPr xmlns:ns3="http://schemas.openxmlformats.org/wordprocessingml/2006/main" sz="1400" b="1" ns3:eastAsia="Microsoft JhengHei">
                 <a:solidFill>
                   <a:srgbClr val="1B2A4A"/>
                 </a:solidFill>
@@ -7386,7 +7774,7 @@
           </a:fontRef>
         </p:style>
         <p:txBody>
-          <a:bodyPr rtlCol="0" anchor="ctr"/>
+          <a:bodyPr rtlCol="0" anchor="ctr" wrap="square"/>
           <a:lstStyle/>
           <a:p>
             <a:pPr algn="ctr"/>
@@ -7429,7 +7817,7 @@
           </a:fontRef>
         </p:style>
         <p:txBody>
-          <a:bodyPr rtlCol="0" anchor="ctr"/>
+          <a:bodyPr rtlCol="0" anchor="ctr" wrap="square"/>
           <a:lstStyle/>
           <a:p>
             <a:pPr algn="ctr"/>
@@ -7460,7 +7848,7 @@
           <a:p>
             <a:pPr algn="l"/>
             <a:r>
-              <a:rPr sz="1400" b="1">
+              <a:rPr xmlns:ns4="http://schemas.openxmlformats.org/wordprocessingml/2006/main" sz="1400" b="1" ns4:eastAsia="Microsoft JhengHei">
                 <a:solidFill>
                   <a:srgbClr val="1B2A4A"/>
                 </a:solidFill>
@@ -7510,7 +7898,7 @@
           </a:fontRef>
         </p:style>
         <p:txBody>
-          <a:bodyPr rtlCol="0" anchor="ctr"/>
+          <a:bodyPr rtlCol="0" anchor="ctr" wrap="square"/>
           <a:lstStyle/>
           <a:p>
             <a:pPr algn="ctr"/>
@@ -7553,7 +7941,7 @@
           </a:fontRef>
         </p:style>
         <p:txBody>
-          <a:bodyPr rtlCol="0" anchor="ctr"/>
+          <a:bodyPr rtlCol="0" anchor="ctr" wrap="square"/>
           <a:lstStyle/>
           <a:p>
             <a:pPr algn="ctr"/>
@@ -7584,7 +7972,7 @@
           <a:p>
             <a:pPr algn="l"/>
             <a:r>
-              <a:rPr sz="1400" b="1">
+              <a:rPr xmlns:ns5="http://schemas.openxmlformats.org/wordprocessingml/2006/main" sz="1400" b="1" ns5:eastAsia="Microsoft JhengHei">
                 <a:solidFill>
                   <a:srgbClr val="1B2A4A"/>
                 </a:solidFill>
@@ -7634,7 +8022,7 @@
           </a:fontRef>
         </p:style>
         <p:txBody>
-          <a:bodyPr rtlCol="0" anchor="ctr"/>
+          <a:bodyPr rtlCol="0" anchor="ctr" wrap="square"/>
           <a:lstStyle/>
           <a:p>
             <a:pPr algn="ctr"/>
@@ -7677,7 +8065,7 @@
           </a:fontRef>
         </p:style>
         <p:txBody>
-          <a:bodyPr rtlCol="0" anchor="ctr"/>
+          <a:bodyPr rtlCol="0" anchor="ctr" wrap="square"/>
           <a:lstStyle/>
           <a:p>
             <a:pPr algn="ctr"/>
@@ -7708,7 +8096,7 @@
           <a:p>
             <a:pPr algn="l"/>
             <a:r>
-              <a:rPr sz="1400" b="1">
+              <a:rPr xmlns:ns6="http://schemas.openxmlformats.org/wordprocessingml/2006/main" sz="1400" b="1" ns6:eastAsia="Microsoft JhengHei">
                 <a:solidFill>
                   <a:srgbClr val="1B2A4A"/>
                 </a:solidFill>
@@ -7758,7 +8146,7 @@
           </a:fontRef>
         </p:style>
         <p:txBody>
-          <a:bodyPr rtlCol="0" anchor="ctr"/>
+          <a:bodyPr rtlCol="0" anchor="ctr" wrap="square"/>
           <a:lstStyle/>
           <a:p>
             <a:pPr algn="ctr"/>
@@ -7801,7 +8189,7 @@
           </a:fontRef>
         </p:style>
         <p:txBody>
-          <a:bodyPr rtlCol="0" anchor="ctr"/>
+          <a:bodyPr rtlCol="0" anchor="ctr" wrap="square"/>
           <a:lstStyle/>
           <a:p>
             <a:pPr algn="ctr"/>
@@ -7832,7 +8220,7 @@
           <a:p>
             <a:pPr algn="l"/>
             <a:r>
-              <a:rPr sz="1400" b="1">
+              <a:rPr xmlns:ns7="http://schemas.openxmlformats.org/wordprocessingml/2006/main" sz="1400" b="1" ns7:eastAsia="Microsoft JhengHei">
                 <a:solidFill>
                   <a:srgbClr val="1B2A4A"/>
                 </a:solidFill>
@@ -7861,22 +8249,101 @@
           <a:noFill/>
         </p:spPr>
         <p:txBody>
-          <a:bodyPr wrap="none">
+          <a:bodyPr wrap="square">
             <a:spAutoFit/>
           </a:bodyPr>
           <a:lstStyle/>
           <a:p>
             <a:pPr algn="r"/>
             <a:r>
+              <a:rPr xmlns:ns8="http://schemas.openxmlformats.org/wordprocessingml/2006/main" sz="1400" ns8:eastAsia="Microsoft JhengHei">
+                <a:solidFill>
+                  <a:srgbClr val="6B7280"/>
+                </a:solidFill>
+                <a:latin typeface="Microsoft JhengHei"/>
+                <a:rFonts ea="Microsoft JhengHei"/>
+              </a:rPr>
+              <a:t>2</a:t>
+            </a:r>
+          </a:p>
+        </p:txBody>
+      </p:sp>
+      <p:sp>
+        <p:nvSpPr>
+          <p:cNvPr id="23" name="TextBox 22"/>
+          <p:cNvSpPr txBox="1"/>
+          <p:nvPr/>
+        </p:nvSpPr>
+        <p:spPr>
+          <a:xfrm>
+            <a:off x="11247120" y="6446520"/>
+            <a:ext cx="731520" cy="274320"/>
+          </a:xfrm>
+          <a:prstGeom prst="rect">
+            <a:avLst/>
+          </a:prstGeom>
+          <a:noFill/>
+        </p:spPr>
+        <p:txBody>
+          <a:bodyPr wrap="square">
+            <a:spAutoFit/>
+          </a:bodyPr>
+          <a:lstStyle/>
+          <a:p>
+            <a:pPr algn="r"/>
+            <a:r>
               <a:rPr sz="900">
                 <a:solidFill>
                   <a:srgbClr val="6B7280"/>
                 </a:solidFill>
                 <a:latin typeface="Microsoft JhengHei"/>
-                <a:rFonts ea="Microsoft JhengHei"/>
+                <a:rFonts a:ea="Microsoft JhengHei"/>
               </a:rPr>
               <a:t>2</a:t>
             </a:r>
+          </a:p>
+        </p:txBody>
+      </p:sp>
+      <p:sp>
+        <p:nvSpPr>
+          <p:cNvPr id="24" name="Rectangle 23"/>
+          <p:cNvSpPr/>
+          <p:nvPr/>
+        </p:nvSpPr>
+        <p:spPr>
+          <a:xfrm>
+            <a:off x="320040" y="1371600"/>
+            <a:ext cx="73152" cy="5029200"/>
+          </a:xfrm>
+          <a:prstGeom prst="rect">
+            <a:avLst/>
+          </a:prstGeom>
+          <a:solidFill>
+            <a:srgbClr val="0E7C86"/>
+          </a:solidFill>
+          <a:ln>
+            <a:noFill/>
+          </a:ln>
+        </p:spPr>
+        <p:style>
+          <a:lnRef idx="1">
+            <a:schemeClr val="accent1"/>
+          </a:lnRef>
+          <a:fillRef idx="3">
+            <a:schemeClr val="accent1"/>
+          </a:fillRef>
+          <a:effectRef idx="2">
+            <a:schemeClr val="accent1"/>
+          </a:effectRef>
+          <a:fontRef idx="minor">
+            <a:schemeClr val="lt1"/>
+          </a:fontRef>
+        </p:style>
+        <p:txBody>
+          <a:bodyPr rtlCol="0" anchor="ctr" wrap="square"/>
+          <a:lstStyle/>
+          <a:p>
+            <a:pPr algn="ctr"/>
           </a:p>
         </p:txBody>
       </p:sp>
@@ -7930,7 +8397,7 @@
           <a:p>
             <a:pPr algn="l"/>
             <a:r>
-              <a:rPr sz="3000" b="1">
+              <a:rPr xmlns:ns0="http://schemas.openxmlformats.org/wordprocessingml/2006/main" sz="3000" b="1" ns0:eastAsia="Microsoft JhengHei">
                 <a:solidFill>
                   <a:srgbClr val="1B2A4A"/>
                 </a:solidFill>
@@ -7966,7 +8433,7 @@
           <a:p>
             <a:pPr algn="l"/>
             <a:r>
-              <a:rPr sz="1400">
+              <a:rPr xmlns:ns1="http://schemas.openxmlformats.org/wordprocessingml/2006/main" sz="1400" ns1:eastAsia="Microsoft JhengHei">
                 <a:solidFill>
                   <a:srgbClr val="0E7C86"/>
                 </a:solidFill>
@@ -8016,7 +8483,7 @@
           </a:fontRef>
         </p:style>
         <p:txBody>
-          <a:bodyPr rtlCol="0" anchor="ctr"/>
+          <a:bodyPr rtlCol="0" anchor="ctr" wrap="square"/>
           <a:lstStyle/>
           <a:p>
             <a:pPr algn="ctr"/>
@@ -8047,7 +8514,7 @@
           <a:p>
             <a:pPr algn="ctr"/>
             <a:r>
-              <a:rPr sz="2600" b="1">
+              <a:rPr xmlns:ns2="http://schemas.openxmlformats.org/wordprocessingml/2006/main" sz="2600" b="1" ns2:eastAsia="Microsoft JhengHei">
                 <a:solidFill>
                   <a:srgbClr val="1B2A4A"/>
                 </a:solidFill>
@@ -8097,7 +8564,7 @@
           </a:fontRef>
         </p:style>
         <p:txBody>
-          <a:bodyPr rtlCol="0" anchor="ctr"/>
+          <a:bodyPr rtlCol="0" anchor="ctr" wrap="square"/>
           <a:lstStyle/>
           <a:p>
             <a:pPr algn="ctr"/>
@@ -8140,7 +8607,7 @@
           </a:fontRef>
         </p:style>
         <p:txBody>
-          <a:bodyPr rtlCol="0" anchor="ctr"/>
+          <a:bodyPr rtlCol="0" anchor="ctr" wrap="square"/>
           <a:lstStyle/>
           <a:p>
             <a:pPr algn="ctr"/>
@@ -8177,7 +8644,7 @@
               </a:defRPr>
             </a:pPr>
             <a:r>
-              <a:rPr sz="1100">
+              <a:rPr xmlns:ns3="http://schemas.openxmlformats.org/wordprocessingml/2006/main" sz="1400" ns3:eastAsia="Microsoft JhengHei">
                 <a:solidFill>
                   <a:srgbClr val="3A4A63"/>
                 </a:solidFill>
@@ -8231,7 +8698,7 @@
           </a:fontRef>
         </p:style>
         <p:txBody>
-          <a:bodyPr rtlCol="0" anchor="ctr"/>
+          <a:bodyPr rtlCol="0" anchor="ctr" wrap="square"/>
           <a:lstStyle/>
           <a:p>
             <a:pPr algn="ctr"/>
@@ -8274,7 +8741,7 @@
           </a:fontRef>
         </p:style>
         <p:txBody>
-          <a:bodyPr rtlCol="0" anchor="ctr"/>
+          <a:bodyPr rtlCol="0" anchor="ctr" wrap="square"/>
           <a:lstStyle/>
           <a:p>
             <a:pPr algn="ctr"/>
@@ -8311,7 +8778,7 @@
               </a:defRPr>
             </a:pPr>
             <a:r>
-              <a:rPr sz="1100">
+              <a:rPr xmlns:ns4="http://schemas.openxmlformats.org/wordprocessingml/2006/main" sz="1400" ns4:eastAsia="Microsoft JhengHei">
                 <a:solidFill>
                   <a:srgbClr val="3A4A63"/>
                 </a:solidFill>
@@ -8363,7 +8830,7 @@
           </a:fontRef>
         </p:style>
         <p:txBody>
-          <a:bodyPr rtlCol="0" anchor="ctr"/>
+          <a:bodyPr rtlCol="0" anchor="ctr" wrap="square"/>
           <a:lstStyle/>
           <a:p>
             <a:pPr algn="ctr"/>
@@ -8394,7 +8861,7 @@
           <a:p>
             <a:pPr algn="ctr"/>
             <a:r>
-              <a:rPr sz="1150" b="1">
+              <a:rPr xmlns:ns5="http://schemas.openxmlformats.org/wordprocessingml/2006/main" sz="1400" b="1" ns5:eastAsia="Microsoft JhengHei">
                 <a:solidFill>
                   <a:srgbClr val="0E7C86"/>
                 </a:solidFill>
@@ -8423,21 +8890,155 @@
           <a:noFill/>
         </p:spPr>
         <p:txBody>
-          <a:bodyPr wrap="none">
+          <a:bodyPr wrap="square">
             <a:spAutoFit/>
           </a:bodyPr>
           <a:lstStyle/>
           <a:p>
             <a:pPr algn="r"/>
             <a:r>
+              <a:rPr xmlns:ns6="http://schemas.openxmlformats.org/wordprocessingml/2006/main" sz="1400" ns6:eastAsia="Microsoft JhengHei">
+                <a:solidFill>
+                  <a:srgbClr val="6B7280"/>
+                </a:solidFill>
+                <a:latin typeface="Microsoft JhengHei"/>
+                <a:rFonts ea="Microsoft JhengHei"/>
+              </a:rPr>
+              <a:t>3</a:t>
+            </a:r>
+          </a:p>
+        </p:txBody>
+      </p:sp>
+      <p:sp>
+        <p:nvSpPr>
+          <p:cNvPr id="15" name="TextBox 14"/>
+          <p:cNvSpPr txBox="1"/>
+          <p:nvPr/>
+        </p:nvSpPr>
+        <p:spPr>
+          <a:xfrm>
+            <a:off x="11247120" y="6446520"/>
+            <a:ext cx="731520" cy="274320"/>
+          </a:xfrm>
+          <a:prstGeom prst="rect">
+            <a:avLst/>
+          </a:prstGeom>
+          <a:noFill/>
+        </p:spPr>
+        <p:txBody>
+          <a:bodyPr wrap="square">
+            <a:spAutoFit/>
+          </a:bodyPr>
+          <a:lstStyle/>
+          <a:p>
+            <a:pPr algn="r"/>
+            <a:r>
               <a:rPr sz="900">
                 <a:solidFill>
                   <a:srgbClr val="6B7280"/>
                 </a:solidFill>
                 <a:latin typeface="Microsoft JhengHei"/>
-                <a:rFonts ea="Microsoft JhengHei"/>
+                <a:rFonts a:ea="Microsoft JhengHei"/>
               </a:rPr>
               <a:t>3</a:t>
+            </a:r>
+          </a:p>
+        </p:txBody>
+      </p:sp>
+      <p:sp>
+        <p:nvSpPr>
+          <p:cNvPr id="16" name="Rectangle 15"/>
+          <p:cNvSpPr/>
+          <p:nvPr/>
+        </p:nvSpPr>
+        <p:spPr>
+          <a:xfrm>
+            <a:off x="320040" y="1371600"/>
+            <a:ext cx="73152" cy="5029200"/>
+          </a:xfrm>
+          <a:prstGeom prst="rect">
+            <a:avLst/>
+          </a:prstGeom>
+          <a:solidFill>
+            <a:srgbClr val="1B2A4A"/>
+          </a:solidFill>
+          <a:ln>
+            <a:noFill/>
+          </a:ln>
+        </p:spPr>
+        <p:style>
+          <a:lnRef idx="1">
+            <a:schemeClr val="accent1"/>
+          </a:lnRef>
+          <a:fillRef idx="3">
+            <a:schemeClr val="accent1"/>
+          </a:fillRef>
+          <a:effectRef idx="2">
+            <a:schemeClr val="accent1"/>
+          </a:effectRef>
+          <a:fontRef idx="minor">
+            <a:schemeClr val="lt1"/>
+          </a:fontRef>
+        </p:style>
+        <p:txBody>
+          <a:bodyPr rtlCol="0" anchor="ctr" wrap="square"/>
+          <a:lstStyle/>
+          <a:p>
+            <a:pPr algn="ctr"/>
+          </a:p>
+        </p:txBody>
+      </p:sp>
+      <p:sp>
+        <p:nvSpPr>
+          <p:cNvPr id="17" name="Rounded Rectangle 16"/>
+          <p:cNvSpPr/>
+          <p:nvPr/>
+        </p:nvSpPr>
+        <p:spPr>
+          <a:xfrm>
+            <a:off x="457200" y="5943600"/>
+            <a:ext cx="11247120" cy="502920"/>
+          </a:xfrm>
+          <a:prstGeom prst="roundRect">
+            <a:avLst/>
+          </a:prstGeom>
+          <a:solidFill>
+            <a:srgbClr val="E7F1F2"/>
+          </a:solidFill>
+          <a:ln w="9525">
+            <a:solidFill>
+              <a:srgbClr val="D8DEE7"/>
+            </a:solidFill>
+          </a:ln>
+        </p:spPr>
+        <p:style>
+          <a:lnRef idx="1">
+            <a:schemeClr val="accent1"/>
+          </a:lnRef>
+          <a:fillRef idx="3">
+            <a:schemeClr val="accent1"/>
+          </a:fillRef>
+          <a:effectRef idx="2">
+            <a:schemeClr val="accent1"/>
+          </a:effectRef>
+          <a:fontRef idx="minor">
+            <a:schemeClr val="lt1"/>
+          </a:fontRef>
+        </p:style>
+        <p:txBody>
+          <a:bodyPr rtlCol="0" anchor="ctr" wrap="square"/>
+          <a:lstStyle/>
+          <a:p>
+            <a:pPr algn="ctr"/>
+            <a:r>
+              <a:rPr xmlns:ns7="http://schemas.openxmlformats.org/wordprocessingml/2006/main" sz="1400" b="1" ns7:eastAsia="Microsoft JhengHei">
+                <a:solidFill>
+                  <a:srgbClr val="0E7C86"/>
+                </a:solidFill>
+                <a:latin typeface="Microsoft JhengHei"/>
+                <a:rFonts a:ea="Microsoft JhengHei"/>
+              </a:rPr>
+              <a:t>實證：Jimenez 等人僅優化 Harness 層即將 SWE-bench 解決率從 12% 提升至 76%；Bölük 證實 15 種不同 LLM 皆獲一致性能提升</a:t>
             </a:r>
           </a:p>
         </p:txBody>
@@ -8492,7 +9093,7 @@
           <a:p>
             <a:pPr algn="l"/>
             <a:r>
-              <a:rPr sz="3000" b="1">
+              <a:rPr xmlns:ns0="http://schemas.openxmlformats.org/wordprocessingml/2006/main" sz="3000" b="1" ns0:eastAsia="Microsoft JhengHei">
                 <a:solidFill>
                   <a:srgbClr val="1B2A4A"/>
                 </a:solidFill>
@@ -8528,7 +9129,7 @@
           <a:p>
             <a:pPr algn="l"/>
             <a:r>
-              <a:rPr sz="1400">
+              <a:rPr xmlns:ns1="http://schemas.openxmlformats.org/wordprocessingml/2006/main" sz="1400" ns1:eastAsia="Microsoft JhengHei">
                 <a:solidFill>
                   <a:srgbClr val="0E7C86"/>
                 </a:solidFill>
@@ -8578,7 +9179,7 @@
           </a:fontRef>
         </p:style>
         <p:txBody>
-          <a:bodyPr rtlCol="0" anchor="ctr"/>
+          <a:bodyPr rtlCol="0" anchor="ctr" wrap="square"/>
           <a:lstStyle/>
           <a:p>
             <a:pPr algn="ctr"/>
@@ -8621,7 +9222,7 @@
           </a:fontRef>
         </p:style>
         <p:txBody>
-          <a:bodyPr rtlCol="0" anchor="ctr"/>
+          <a:bodyPr rtlCol="0" anchor="ctr" wrap="square"/>
           <a:lstStyle/>
           <a:p>
             <a:pPr algn="ctr"/>
@@ -8652,7 +9253,7 @@
           <a:p>
             <a:pPr algn="l"/>
             <a:r>
-              <a:rPr sz="1400" b="1">
+              <a:rPr xmlns:ns2="http://schemas.openxmlformats.org/wordprocessingml/2006/main" sz="1400" b="1" ns2:eastAsia="Microsoft JhengHei">
                 <a:solidFill>
                   <a:srgbClr val="1B2A4A"/>
                 </a:solidFill>
@@ -8688,7 +9289,7 @@
           <a:p>
             <a:pPr algn="l"/>
             <a:r>
-              <a:rPr sz="1100">
+              <a:rPr xmlns:ns3="http://schemas.openxmlformats.org/wordprocessingml/2006/main" sz="1400" ns3:eastAsia="Microsoft JhengHei">
                 <a:solidFill>
                   <a:srgbClr val="3A4A63"/>
                 </a:solidFill>
@@ -8739,7 +9340,7 @@
           </a:fontRef>
         </p:style>
         <p:txBody>
-          <a:bodyPr rtlCol="0" anchor="ctr"/>
+          <a:bodyPr rtlCol="0" anchor="ctr" wrap="square"/>
           <a:lstStyle/>
           <a:p>
             <a:pPr algn="ctr"/>
@@ -8782,7 +9383,7 @@
           </a:fontRef>
         </p:style>
         <p:txBody>
-          <a:bodyPr rtlCol="0" anchor="ctr"/>
+          <a:bodyPr rtlCol="0" anchor="ctr" wrap="square"/>
           <a:lstStyle/>
           <a:p>
             <a:pPr algn="ctr"/>
@@ -8813,7 +9414,7 @@
           <a:p>
             <a:pPr algn="l"/>
             <a:r>
-              <a:rPr sz="1400" b="1">
+              <a:rPr xmlns:ns4="http://schemas.openxmlformats.org/wordprocessingml/2006/main" sz="1400" b="1" ns4:eastAsia="Microsoft JhengHei">
                 <a:solidFill>
                   <a:srgbClr val="1B2A4A"/>
                 </a:solidFill>
@@ -8849,7 +9450,7 @@
           <a:p>
             <a:pPr algn="l"/>
             <a:r>
-              <a:rPr sz="1100">
+              <a:rPr xmlns:ns5="http://schemas.openxmlformats.org/wordprocessingml/2006/main" sz="1400" ns5:eastAsia="Microsoft JhengHei">
                 <a:solidFill>
                   <a:srgbClr val="3A4A63"/>
                 </a:solidFill>
@@ -8900,7 +9501,7 @@
           </a:fontRef>
         </p:style>
         <p:txBody>
-          <a:bodyPr rtlCol="0" anchor="ctr"/>
+          <a:bodyPr rtlCol="0" anchor="ctr" wrap="square"/>
           <a:lstStyle/>
           <a:p>
             <a:pPr algn="ctr"/>
@@ -8943,7 +9544,7 @@
           </a:fontRef>
         </p:style>
         <p:txBody>
-          <a:bodyPr rtlCol="0" anchor="ctr"/>
+          <a:bodyPr rtlCol="0" anchor="ctr" wrap="square"/>
           <a:lstStyle/>
           <a:p>
             <a:pPr algn="ctr"/>
@@ -8974,7 +9575,7 @@
           <a:p>
             <a:pPr algn="l"/>
             <a:r>
-              <a:rPr sz="1400" b="1">
+              <a:rPr xmlns:ns6="http://schemas.openxmlformats.org/wordprocessingml/2006/main" sz="1400" b="1" ns6:eastAsia="Microsoft JhengHei">
                 <a:solidFill>
                   <a:srgbClr val="1B2A4A"/>
                 </a:solidFill>
@@ -9010,7 +9611,7 @@
           <a:p>
             <a:pPr algn="l"/>
             <a:r>
-              <a:rPr sz="1100">
+              <a:rPr xmlns:ns7="http://schemas.openxmlformats.org/wordprocessingml/2006/main" sz="1400" ns7:eastAsia="Microsoft JhengHei">
                 <a:solidFill>
                   <a:srgbClr val="3A4A63"/>
                 </a:solidFill>
@@ -9059,7 +9660,7 @@
           </a:fontRef>
         </p:style>
         <p:txBody>
-          <a:bodyPr rtlCol="0" anchor="ctr"/>
+          <a:bodyPr rtlCol="0" anchor="ctr" wrap="square"/>
           <a:lstStyle/>
           <a:p>
             <a:pPr algn="ctr"/>
@@ -9090,7 +9691,7 @@
           <a:p>
             <a:pPr algn="ctr"/>
             <a:r>
-              <a:rPr sz="1150" b="1">
+              <a:rPr xmlns:ns8="http://schemas.openxmlformats.org/wordprocessingml/2006/main" sz="1400" b="1" ns8:eastAsia="Microsoft JhengHei">
                 <a:solidFill>
                   <a:srgbClr val="0E7C86"/>
                 </a:solidFill>
@@ -9119,22 +9720,101 @@
           <a:noFill/>
         </p:spPr>
         <p:txBody>
-          <a:bodyPr wrap="none">
+          <a:bodyPr wrap="square">
             <a:spAutoFit/>
           </a:bodyPr>
           <a:lstStyle/>
           <a:p>
             <a:pPr algn="r"/>
             <a:r>
+              <a:rPr xmlns:ns9="http://schemas.openxmlformats.org/wordprocessingml/2006/main" sz="1400" ns9:eastAsia="Microsoft JhengHei">
+                <a:solidFill>
+                  <a:srgbClr val="6B7280"/>
+                </a:solidFill>
+                <a:latin typeface="Microsoft JhengHei"/>
+                <a:rFonts ea="Microsoft JhengHei"/>
+              </a:rPr>
+              <a:t>4</a:t>
+            </a:r>
+          </a:p>
+        </p:txBody>
+      </p:sp>
+      <p:sp>
+        <p:nvSpPr>
+          <p:cNvPr id="19" name="TextBox 18"/>
+          <p:cNvSpPr txBox="1"/>
+          <p:nvPr/>
+        </p:nvSpPr>
+        <p:spPr>
+          <a:xfrm>
+            <a:off x="11247120" y="6446520"/>
+            <a:ext cx="731520" cy="274320"/>
+          </a:xfrm>
+          <a:prstGeom prst="rect">
+            <a:avLst/>
+          </a:prstGeom>
+          <a:noFill/>
+        </p:spPr>
+        <p:txBody>
+          <a:bodyPr wrap="square">
+            <a:spAutoFit/>
+          </a:bodyPr>
+          <a:lstStyle/>
+          <a:p>
+            <a:pPr algn="r"/>
+            <a:r>
               <a:rPr sz="900">
                 <a:solidFill>
                   <a:srgbClr val="6B7280"/>
                 </a:solidFill>
                 <a:latin typeface="Microsoft JhengHei"/>
-                <a:rFonts ea="Microsoft JhengHei"/>
+                <a:rFonts a:ea="Microsoft JhengHei"/>
               </a:rPr>
               <a:t>4</a:t>
             </a:r>
+          </a:p>
+        </p:txBody>
+      </p:sp>
+      <p:sp>
+        <p:nvSpPr>
+          <p:cNvPr id="20" name="Rectangle 19"/>
+          <p:cNvSpPr/>
+          <p:nvPr/>
+        </p:nvSpPr>
+        <p:spPr>
+          <a:xfrm>
+            <a:off x="320040" y="1371600"/>
+            <a:ext cx="73152" cy="5029200"/>
+          </a:xfrm>
+          <a:prstGeom prst="rect">
+            <a:avLst/>
+          </a:prstGeom>
+          <a:solidFill>
+            <a:srgbClr val="C8891B"/>
+          </a:solidFill>
+          <a:ln>
+            <a:noFill/>
+          </a:ln>
+        </p:spPr>
+        <p:style>
+          <a:lnRef idx="1">
+            <a:schemeClr val="accent1"/>
+          </a:lnRef>
+          <a:fillRef idx="3">
+            <a:schemeClr val="accent1"/>
+          </a:fillRef>
+          <a:effectRef idx="2">
+            <a:schemeClr val="accent1"/>
+          </a:effectRef>
+          <a:fontRef idx="minor">
+            <a:schemeClr val="lt1"/>
+          </a:fontRef>
+        </p:style>
+        <p:txBody>
+          <a:bodyPr rtlCol="0" anchor="ctr" wrap="square"/>
+          <a:lstStyle/>
+          <a:p>
+            <a:pPr algn="ctr"/>
           </a:p>
         </p:txBody>
       </p:sp>
@@ -9188,7 +9868,7 @@
           <a:p>
             <a:pPr algn="l"/>
             <a:r>
-              <a:rPr sz="3000" b="1">
+              <a:rPr xmlns:ns0="http://schemas.openxmlformats.org/wordprocessingml/2006/main" sz="3000" b="1" ns0:eastAsia="Microsoft JhengHei">
                 <a:solidFill>
                   <a:srgbClr val="1B2A4A"/>
                 </a:solidFill>
@@ -9224,7 +9904,7 @@
           <a:p>
             <a:pPr algn="l"/>
             <a:r>
-              <a:rPr sz="1400">
+              <a:rPr xmlns:ns1="http://schemas.openxmlformats.org/wordprocessingml/2006/main" sz="1400" ns1:eastAsia="Microsoft JhengHei">
                 <a:solidFill>
                   <a:srgbClr val="0E7C86"/>
                 </a:solidFill>
@@ -9274,7 +9954,7 @@
           </a:fontRef>
         </p:style>
         <p:txBody>
-          <a:bodyPr rtlCol="0" anchor="ctr"/>
+          <a:bodyPr rtlCol="0" anchor="ctr" wrap="square"/>
           <a:lstStyle/>
           <a:p>
             <a:pPr algn="ctr"/>
@@ -9317,7 +9997,7 @@
           </a:fontRef>
         </p:style>
         <p:txBody>
-          <a:bodyPr rtlCol="0" anchor="ctr"/>
+          <a:bodyPr rtlCol="0" anchor="ctr" wrap="square"/>
           <a:lstStyle/>
           <a:p>
             <a:pPr algn="ctr"/>
@@ -9348,7 +10028,7 @@
           <a:p>
             <a:pPr algn="l"/>
             <a:r>
-              <a:rPr sz="1400" b="1">
+              <a:rPr xmlns:ns2="http://schemas.openxmlformats.org/wordprocessingml/2006/main" sz="1400" b="1" ns2:eastAsia="Microsoft JhengHei">
                 <a:solidFill>
                   <a:srgbClr val="3B82F6"/>
                 </a:solidFill>
@@ -9384,7 +10064,7 @@
           <a:p>
             <a:pPr algn="l"/>
             <a:r>
-              <a:rPr sz="1400" b="1">
+              <a:rPr xmlns:ns3="http://schemas.openxmlformats.org/wordprocessingml/2006/main" sz="1400" b="1" ns3:eastAsia="Microsoft JhengHei">
                 <a:solidFill>
                   <a:srgbClr val="1B2A4A"/>
                 </a:solidFill>
@@ -9420,7 +10100,7 @@
           <a:p>
             <a:pPr algn="l"/>
             <a:r>
-              <a:rPr sz="1100">
+              <a:rPr xmlns:ns4="http://schemas.openxmlformats.org/wordprocessingml/2006/main" sz="1400" ns4:eastAsia="Microsoft JhengHei">
                 <a:solidFill>
                   <a:srgbClr val="3A4A63"/>
                 </a:solidFill>
@@ -9470,7 +10150,7 @@
           </a:fontRef>
         </p:style>
         <p:txBody>
-          <a:bodyPr rtlCol="0" anchor="ctr"/>
+          <a:bodyPr rtlCol="0" anchor="ctr" wrap="square"/>
           <a:lstStyle/>
           <a:p>
             <a:pPr algn="ctr"/>
@@ -9513,7 +10193,7 @@
           </a:fontRef>
         </p:style>
         <p:txBody>
-          <a:bodyPr rtlCol="0" anchor="ctr"/>
+          <a:bodyPr rtlCol="0" anchor="ctr" wrap="square"/>
           <a:lstStyle/>
           <a:p>
             <a:pPr algn="ctr"/>
@@ -9544,7 +10224,7 @@
           <a:p>
             <a:pPr algn="l"/>
             <a:r>
-              <a:rPr sz="1400" b="1">
+              <a:rPr xmlns:ns5="http://schemas.openxmlformats.org/wordprocessingml/2006/main" sz="1400" b="1" ns5:eastAsia="Microsoft JhengHei">
                 <a:solidFill>
                   <a:srgbClr val="F5A623"/>
                 </a:solidFill>
@@ -9580,7 +10260,7 @@
           <a:p>
             <a:pPr algn="l"/>
             <a:r>
-              <a:rPr sz="1400" b="1">
+              <a:rPr xmlns:ns6="http://schemas.openxmlformats.org/wordprocessingml/2006/main" sz="1400" b="1" ns6:eastAsia="Microsoft JhengHei">
                 <a:solidFill>
                   <a:srgbClr val="1B2A4A"/>
                 </a:solidFill>
@@ -9616,7 +10296,7 @@
           <a:p>
             <a:pPr algn="l"/>
             <a:r>
-              <a:rPr sz="1100">
+              <a:rPr xmlns:ns7="http://schemas.openxmlformats.org/wordprocessingml/2006/main" sz="1400" ns7:eastAsia="Microsoft JhengHei">
                 <a:solidFill>
                   <a:srgbClr val="3A4A63"/>
                 </a:solidFill>
@@ -9666,7 +10346,7 @@
           </a:fontRef>
         </p:style>
         <p:txBody>
-          <a:bodyPr rtlCol="0" anchor="ctr"/>
+          <a:bodyPr rtlCol="0" anchor="ctr" wrap="square"/>
           <a:lstStyle/>
           <a:p>
             <a:pPr algn="ctr"/>
@@ -9709,7 +10389,7 @@
           </a:fontRef>
         </p:style>
         <p:txBody>
-          <a:bodyPr rtlCol="0" anchor="ctr"/>
+          <a:bodyPr rtlCol="0" anchor="ctr" wrap="square"/>
           <a:lstStyle/>
           <a:p>
             <a:pPr algn="ctr"/>
@@ -9740,7 +10420,7 @@
           <a:p>
             <a:pPr algn="l"/>
             <a:r>
-              <a:rPr sz="1400" b="1">
+              <a:rPr xmlns:ns8="http://schemas.openxmlformats.org/wordprocessingml/2006/main" sz="1400" b="1" ns8:eastAsia="Microsoft JhengHei">
                 <a:solidFill>
                   <a:srgbClr val="8B5CF6"/>
                 </a:solidFill>
@@ -9776,7 +10456,7 @@
           <a:p>
             <a:pPr algn="l"/>
             <a:r>
-              <a:rPr sz="1400" b="1">
+              <a:rPr xmlns:ns9="http://schemas.openxmlformats.org/wordprocessingml/2006/main" sz="1400" b="1" ns9:eastAsia="Microsoft JhengHei">
                 <a:solidFill>
                   <a:srgbClr val="1B2A4A"/>
                 </a:solidFill>
@@ -9812,7 +10492,7 @@
           <a:p>
             <a:pPr algn="l"/>
             <a:r>
-              <a:rPr sz="1100">
+              <a:rPr xmlns:ns10="http://schemas.openxmlformats.org/wordprocessingml/2006/main" sz="1400" ns10:eastAsia="Microsoft JhengHei">
                 <a:solidFill>
                   <a:srgbClr val="3A4A63"/>
                 </a:solidFill>
@@ -9862,7 +10542,7 @@
           </a:fontRef>
         </p:style>
         <p:txBody>
-          <a:bodyPr rtlCol="0" anchor="ctr"/>
+          <a:bodyPr rtlCol="0" anchor="ctr" wrap="square"/>
           <a:lstStyle/>
           <a:p>
             <a:pPr algn="ctr"/>
@@ -9905,7 +10585,7 @@
           </a:fontRef>
         </p:style>
         <p:txBody>
-          <a:bodyPr rtlCol="0" anchor="ctr"/>
+          <a:bodyPr rtlCol="0" anchor="ctr" wrap="square"/>
           <a:lstStyle/>
           <a:p>
             <a:pPr algn="ctr"/>
@@ -9936,7 +10616,7 @@
           <a:p>
             <a:pPr algn="l"/>
             <a:r>
-              <a:rPr sz="1400" b="1">
+              <a:rPr xmlns:ns11="http://schemas.openxmlformats.org/wordprocessingml/2006/main" sz="1400" b="1" ns11:eastAsia="Microsoft JhengHei">
                 <a:solidFill>
                   <a:srgbClr val="10B981"/>
                 </a:solidFill>
@@ -9972,7 +10652,7 @@
           <a:p>
             <a:pPr algn="l"/>
             <a:r>
-              <a:rPr sz="1400" b="1">
+              <a:rPr xmlns:ns12="http://schemas.openxmlformats.org/wordprocessingml/2006/main" sz="1400" b="1" ns12:eastAsia="Microsoft JhengHei">
                 <a:solidFill>
                   <a:srgbClr val="1B2A4A"/>
                 </a:solidFill>
@@ -10008,7 +10688,7 @@
           <a:p>
             <a:pPr algn="l"/>
             <a:r>
-              <a:rPr sz="1100">
+              <a:rPr xmlns:ns13="http://schemas.openxmlformats.org/wordprocessingml/2006/main" sz="1400" ns13:eastAsia="Microsoft JhengHei">
                 <a:solidFill>
                   <a:srgbClr val="3A4A63"/>
                 </a:solidFill>
@@ -10058,7 +10738,7 @@
           </a:fontRef>
         </p:style>
         <p:txBody>
-          <a:bodyPr rtlCol="0" anchor="ctr"/>
+          <a:bodyPr rtlCol="0" anchor="ctr" wrap="square"/>
           <a:lstStyle/>
           <a:p>
             <a:pPr algn="ctr"/>
@@ -10101,7 +10781,7 @@
           </a:fontRef>
         </p:style>
         <p:txBody>
-          <a:bodyPr rtlCol="0" anchor="ctr"/>
+          <a:bodyPr rtlCol="0" anchor="ctr" wrap="square"/>
           <a:lstStyle/>
           <a:p>
             <a:pPr algn="ctr"/>
@@ -10132,7 +10812,7 @@
           <a:p>
             <a:pPr algn="l"/>
             <a:r>
-              <a:rPr sz="1400" b="1">
+              <a:rPr xmlns:ns14="http://schemas.openxmlformats.org/wordprocessingml/2006/main" sz="1400" b="1" ns14:eastAsia="Microsoft JhengHei">
                 <a:solidFill>
                   <a:srgbClr val="E74C3C"/>
                 </a:solidFill>
@@ -10168,7 +10848,7 @@
           <a:p>
             <a:pPr algn="l"/>
             <a:r>
-              <a:rPr sz="1400" b="1">
+              <a:rPr xmlns:ns15="http://schemas.openxmlformats.org/wordprocessingml/2006/main" sz="1400" b="1" ns15:eastAsia="Microsoft JhengHei">
                 <a:solidFill>
                   <a:srgbClr val="1B2A4A"/>
                 </a:solidFill>
@@ -10204,7 +10884,7 @@
           <a:p>
             <a:pPr algn="l"/>
             <a:r>
-              <a:rPr sz="1100">
+              <a:rPr xmlns:ns16="http://schemas.openxmlformats.org/wordprocessingml/2006/main" sz="1400" ns16:eastAsia="Microsoft JhengHei">
                 <a:solidFill>
                   <a:srgbClr val="3A4A63"/>
                 </a:solidFill>
@@ -10254,7 +10934,7 @@
           </a:fontRef>
         </p:style>
         <p:txBody>
-          <a:bodyPr rtlCol="0" anchor="ctr"/>
+          <a:bodyPr rtlCol="0" anchor="ctr" wrap="square"/>
           <a:lstStyle/>
           <a:p>
             <a:pPr algn="ctr"/>
@@ -10297,7 +10977,7 @@
           </a:fontRef>
         </p:style>
         <p:txBody>
-          <a:bodyPr rtlCol="0" anchor="ctr"/>
+          <a:bodyPr rtlCol="0" anchor="ctr" wrap="square"/>
           <a:lstStyle/>
           <a:p>
             <a:pPr algn="ctr"/>
@@ -10328,7 +11008,7 @@
           <a:p>
             <a:pPr algn="l"/>
             <a:r>
-              <a:rPr sz="1400" b="1">
+              <a:rPr xmlns:ns17="http://schemas.openxmlformats.org/wordprocessingml/2006/main" sz="1400" b="1" ns17:eastAsia="Microsoft JhengHei">
                 <a:solidFill>
                   <a:srgbClr val="64748B"/>
                 </a:solidFill>
@@ -10364,7 +11044,7 @@
           <a:p>
             <a:pPr algn="l"/>
             <a:r>
-              <a:rPr sz="1400" b="1">
+              <a:rPr xmlns:ns18="http://schemas.openxmlformats.org/wordprocessingml/2006/main" sz="1400" b="1" ns18:eastAsia="Microsoft JhengHei">
                 <a:solidFill>
                   <a:srgbClr val="1B2A4A"/>
                 </a:solidFill>
@@ -10400,7 +11080,7 @@
           <a:p>
             <a:pPr algn="l"/>
             <a:r>
-              <a:rPr sz="1100">
+              <a:rPr xmlns:ns19="http://schemas.openxmlformats.org/wordprocessingml/2006/main" sz="1400" ns19:eastAsia="Microsoft JhengHei">
                 <a:solidFill>
                   <a:srgbClr val="3A4A63"/>
                 </a:solidFill>
@@ -10429,21 +11109,155 @@
           <a:noFill/>
         </p:spPr>
         <p:txBody>
-          <a:bodyPr wrap="none">
+          <a:bodyPr wrap="square">
             <a:spAutoFit/>
           </a:bodyPr>
           <a:lstStyle/>
           <a:p>
             <a:pPr algn="r"/>
             <a:r>
+              <a:rPr xmlns:ns20="http://schemas.openxmlformats.org/wordprocessingml/2006/main" sz="1400" ns20:eastAsia="Microsoft JhengHei">
+                <a:solidFill>
+                  <a:srgbClr val="6B7280"/>
+                </a:solidFill>
+                <a:latin typeface="Microsoft JhengHei"/>
+                <a:rFonts ea="Microsoft JhengHei"/>
+              </a:rPr>
+              <a:t>5</a:t>
+            </a:r>
+          </a:p>
+        </p:txBody>
+      </p:sp>
+      <p:sp>
+        <p:nvSpPr>
+          <p:cNvPr id="35" name="TextBox 34"/>
+          <p:cNvSpPr txBox="1"/>
+          <p:nvPr/>
+        </p:nvSpPr>
+        <p:spPr>
+          <a:xfrm>
+            <a:off x="11247120" y="6446520"/>
+            <a:ext cx="731520" cy="274320"/>
+          </a:xfrm>
+          <a:prstGeom prst="rect">
+            <a:avLst/>
+          </a:prstGeom>
+          <a:noFill/>
+        </p:spPr>
+        <p:txBody>
+          <a:bodyPr wrap="square">
+            <a:spAutoFit/>
+          </a:bodyPr>
+          <a:lstStyle/>
+          <a:p>
+            <a:pPr algn="r"/>
+            <a:r>
               <a:rPr sz="900">
                 <a:solidFill>
                   <a:srgbClr val="6B7280"/>
                 </a:solidFill>
                 <a:latin typeface="Microsoft JhengHei"/>
-                <a:rFonts ea="Microsoft JhengHei"/>
+                <a:rFonts a:ea="Microsoft JhengHei"/>
               </a:rPr>
               <a:t>5</a:t>
+            </a:r>
+          </a:p>
+        </p:txBody>
+      </p:sp>
+      <p:sp>
+        <p:nvSpPr>
+          <p:cNvPr id="36" name="Rectangle 35"/>
+          <p:cNvSpPr/>
+          <p:nvPr/>
+        </p:nvSpPr>
+        <p:spPr>
+          <a:xfrm>
+            <a:off x="320040" y="1371600"/>
+            <a:ext cx="73152" cy="5029200"/>
+          </a:xfrm>
+          <a:prstGeom prst="rect">
+            <a:avLst/>
+          </a:prstGeom>
+          <a:solidFill>
+            <a:srgbClr val="0E7C86"/>
+          </a:solidFill>
+          <a:ln>
+            <a:noFill/>
+          </a:ln>
+        </p:spPr>
+        <p:style>
+          <a:lnRef idx="1">
+            <a:schemeClr val="accent1"/>
+          </a:lnRef>
+          <a:fillRef idx="3">
+            <a:schemeClr val="accent1"/>
+          </a:fillRef>
+          <a:effectRef idx="2">
+            <a:schemeClr val="accent1"/>
+          </a:effectRef>
+          <a:fontRef idx="minor">
+            <a:schemeClr val="lt1"/>
+          </a:fontRef>
+        </p:style>
+        <p:txBody>
+          <a:bodyPr rtlCol="0" anchor="ctr" wrap="square"/>
+          <a:lstStyle/>
+          <a:p>
+            <a:pPr algn="ctr"/>
+          </a:p>
+        </p:txBody>
+      </p:sp>
+      <p:sp>
+        <p:nvSpPr>
+          <p:cNvPr id="37" name="Rounded Rectangle 36"/>
+          <p:cNvSpPr/>
+          <p:nvPr/>
+        </p:nvSpPr>
+        <p:spPr>
+          <a:xfrm>
+            <a:off x="457200" y="5943600"/>
+            <a:ext cx="11247120" cy="502920"/>
+          </a:xfrm>
+          <a:prstGeom prst="roundRect">
+            <a:avLst/>
+          </a:prstGeom>
+          <a:solidFill>
+            <a:srgbClr val="E7F1F2"/>
+          </a:solidFill>
+          <a:ln w="9525">
+            <a:solidFill>
+              <a:srgbClr val="D8DEE7"/>
+            </a:solidFill>
+          </a:ln>
+        </p:spPr>
+        <p:style>
+          <a:lnRef idx="1">
+            <a:schemeClr val="accent1"/>
+          </a:lnRef>
+          <a:fillRef idx="3">
+            <a:schemeClr val="accent1"/>
+          </a:fillRef>
+          <a:effectRef idx="2">
+            <a:schemeClr val="accent1"/>
+          </a:effectRef>
+          <a:fontRef idx="minor">
+            <a:schemeClr val="lt1"/>
+          </a:fontRef>
+        </p:style>
+        <p:txBody>
+          <a:bodyPr rtlCol="0" anchor="ctr" wrap="square"/>
+          <a:lstStyle/>
+          <a:p>
+            <a:pPr algn="ctr"/>
+            <a:r>
+              <a:rPr xmlns:ns21="http://schemas.openxmlformats.org/wordprocessingml/2006/main" sz="1400" b="1" ns21:eastAsia="Microsoft JhengHei">
+                <a:solidFill>
+                  <a:srgbClr val="0E7C86"/>
+                </a:solidFill>
+                <a:latin typeface="Microsoft JhengHei"/>
+                <a:rFonts a:ea="Microsoft JhengHei"/>
+              </a:rPr>
+              <a:t>TypeScript 開發 | 1,900+ 源檔案 | 51.2 萬行程式碼 | 40+ 工具模組 | 僅 1.6% 為 AI 決策邏輯，98.4% 為 Harness 基礎設施</a:t>
             </a:r>
           </a:p>
         </p:txBody>
@@ -10498,7 +11312,7 @@
           <a:p>
             <a:pPr algn="l"/>
             <a:r>
-              <a:rPr sz="3000" b="1">
+              <a:rPr xmlns:ns0="http://schemas.openxmlformats.org/wordprocessingml/2006/main" sz="3000" b="1" ns0:eastAsia="Microsoft JhengHei">
                 <a:solidFill>
                   <a:srgbClr val="1B2A4A"/>
                 </a:solidFill>
@@ -10534,7 +11348,7 @@
           <a:p>
             <a:pPr algn="l"/>
             <a:r>
-              <a:rPr sz="1400">
+              <a:rPr xmlns:ns1="http://schemas.openxmlformats.org/wordprocessingml/2006/main" sz="1400" ns1:eastAsia="Microsoft JhengHei">
                 <a:solidFill>
                   <a:srgbClr val="0E7C86"/>
                 </a:solidFill>
@@ -10584,7 +11398,7 @@
           </a:fontRef>
         </p:style>
         <p:txBody>
-          <a:bodyPr rtlCol="0" anchor="ctr"/>
+          <a:bodyPr rtlCol="0" anchor="ctr" wrap="square"/>
           <a:lstStyle/>
           <a:p>
             <a:pPr algn="ctr"/>
@@ -10627,7 +11441,7 @@
           </a:fontRef>
         </p:style>
         <p:txBody>
-          <a:bodyPr rtlCol="0" anchor="ctr"/>
+          <a:bodyPr rtlCol="0" anchor="ctr" wrap="square"/>
           <a:lstStyle/>
           <a:p>
             <a:pPr algn="ctr"/>
@@ -10658,7 +11472,7 @@
           <a:p>
             <a:pPr algn="l"/>
             <a:r>
-              <a:rPr sz="1200" b="1">
+              <a:rPr xmlns:ns2="http://schemas.openxmlformats.org/wordprocessingml/2006/main" sz="1400" b="1" ns2:eastAsia="Microsoft JhengHei">
                 <a:solidFill>
                   <a:srgbClr val="1B2A4A"/>
                 </a:solidFill>
@@ -10708,7 +11522,7 @@
           </a:fontRef>
         </p:style>
         <p:txBody>
-          <a:bodyPr rtlCol="0" anchor="ctr"/>
+          <a:bodyPr rtlCol="0" anchor="ctr" wrap="square"/>
           <a:lstStyle/>
           <a:p>
             <a:pPr algn="ctr"/>
@@ -10751,7 +11565,7 @@
           </a:fontRef>
         </p:style>
         <p:txBody>
-          <a:bodyPr rtlCol="0" anchor="ctr"/>
+          <a:bodyPr rtlCol="0" anchor="ctr" wrap="square"/>
           <a:lstStyle/>
           <a:p>
             <a:pPr algn="ctr"/>
@@ -10782,7 +11596,7 @@
           <a:p>
             <a:pPr algn="l"/>
             <a:r>
-              <a:rPr sz="1200" b="1">
+              <a:rPr xmlns:ns3="http://schemas.openxmlformats.org/wordprocessingml/2006/main" sz="1400" b="1" ns3:eastAsia="Microsoft JhengHei">
                 <a:solidFill>
                   <a:srgbClr val="1B2A4A"/>
                 </a:solidFill>
@@ -10832,7 +11646,7 @@
           </a:fontRef>
         </p:style>
         <p:txBody>
-          <a:bodyPr rtlCol="0" anchor="ctr"/>
+          <a:bodyPr rtlCol="0" anchor="ctr" wrap="square"/>
           <a:lstStyle/>
           <a:p>
             <a:pPr algn="ctr"/>
@@ -10875,7 +11689,7 @@
           </a:fontRef>
         </p:style>
         <p:txBody>
-          <a:bodyPr rtlCol="0" anchor="ctr"/>
+          <a:bodyPr rtlCol="0" anchor="ctr" wrap="square"/>
           <a:lstStyle/>
           <a:p>
             <a:pPr algn="ctr"/>
@@ -10906,7 +11720,7 @@
           <a:p>
             <a:pPr algn="l"/>
             <a:r>
-              <a:rPr sz="1200" b="1">
+              <a:rPr xmlns:ns4="http://schemas.openxmlformats.org/wordprocessingml/2006/main" sz="1400" b="1" ns4:eastAsia="Microsoft JhengHei">
                 <a:solidFill>
                   <a:srgbClr val="1B2A4A"/>
                 </a:solidFill>
@@ -10956,7 +11770,7 @@
           </a:fontRef>
         </p:style>
         <p:txBody>
-          <a:bodyPr rtlCol="0" anchor="ctr"/>
+          <a:bodyPr rtlCol="0" anchor="ctr" wrap="square"/>
           <a:lstStyle/>
           <a:p>
             <a:pPr algn="ctr"/>
@@ -10999,7 +11813,7 @@
           </a:fontRef>
         </p:style>
         <p:txBody>
-          <a:bodyPr rtlCol="0" anchor="ctr"/>
+          <a:bodyPr rtlCol="0" anchor="ctr" wrap="square"/>
           <a:lstStyle/>
           <a:p>
             <a:pPr algn="ctr"/>
@@ -11030,7 +11844,7 @@
           <a:p>
             <a:pPr algn="l"/>
             <a:r>
-              <a:rPr sz="1200" b="1">
+              <a:rPr xmlns:ns5="http://schemas.openxmlformats.org/wordprocessingml/2006/main" sz="1400" b="1" ns5:eastAsia="Microsoft JhengHei">
                 <a:solidFill>
                   <a:srgbClr val="1B2A4A"/>
                 </a:solidFill>
@@ -11080,7 +11894,7 @@
           </a:fontRef>
         </p:style>
         <p:txBody>
-          <a:bodyPr rtlCol="0" anchor="ctr"/>
+          <a:bodyPr rtlCol="0" anchor="ctr" wrap="square"/>
           <a:lstStyle/>
           <a:p>
             <a:pPr algn="ctr"/>
@@ -11123,7 +11937,7 @@
           </a:fontRef>
         </p:style>
         <p:txBody>
-          <a:bodyPr rtlCol="0" anchor="ctr"/>
+          <a:bodyPr rtlCol="0" anchor="ctr" wrap="square"/>
           <a:lstStyle/>
           <a:p>
             <a:pPr algn="ctr"/>
@@ -11154,7 +11968,7 @@
           <a:p>
             <a:pPr algn="l"/>
             <a:r>
-              <a:rPr sz="1200" b="1">
+              <a:rPr xmlns:ns6="http://schemas.openxmlformats.org/wordprocessingml/2006/main" sz="1400" b="1" ns6:eastAsia="Microsoft JhengHei">
                 <a:solidFill>
                   <a:srgbClr val="1B2A4A"/>
                 </a:solidFill>
@@ -11204,7 +12018,7 @@
           </a:fontRef>
         </p:style>
         <p:txBody>
-          <a:bodyPr rtlCol="0" anchor="ctr"/>
+          <a:bodyPr rtlCol="0" anchor="ctr" wrap="square"/>
           <a:lstStyle/>
           <a:p>
             <a:pPr algn="ctr"/>
@@ -11247,7 +12061,7 @@
           </a:fontRef>
         </p:style>
         <p:txBody>
-          <a:bodyPr rtlCol="0" anchor="ctr"/>
+          <a:bodyPr rtlCol="0" anchor="ctr" wrap="square"/>
           <a:lstStyle/>
           <a:p>
             <a:pPr algn="ctr"/>
@@ -11278,7 +12092,7 @@
           <a:p>
             <a:pPr algn="l"/>
             <a:r>
-              <a:rPr sz="1200" b="1">
+              <a:rPr xmlns:ns7="http://schemas.openxmlformats.org/wordprocessingml/2006/main" sz="1400" b="1" ns7:eastAsia="Microsoft JhengHei">
                 <a:solidFill>
                   <a:srgbClr val="1B2A4A"/>
                 </a:solidFill>
@@ -11328,7 +12142,7 @@
           </a:fontRef>
         </p:style>
         <p:txBody>
-          <a:bodyPr rtlCol="0" anchor="ctr"/>
+          <a:bodyPr rtlCol="0" anchor="ctr" wrap="square"/>
           <a:lstStyle/>
           <a:p>
             <a:pPr algn="ctr"/>
@@ -11371,7 +12185,7 @@
           </a:fontRef>
         </p:style>
         <p:txBody>
-          <a:bodyPr rtlCol="0" anchor="ctr"/>
+          <a:bodyPr rtlCol="0" anchor="ctr" wrap="square"/>
           <a:lstStyle/>
           <a:p>
             <a:pPr algn="ctr"/>
@@ -11402,7 +12216,7 @@
           <a:p>
             <a:pPr algn="l"/>
             <a:r>
-              <a:rPr sz="1400" b="1">
+              <a:rPr xmlns:ns8="http://schemas.openxmlformats.org/wordprocessingml/2006/main" sz="1400" b="1" ns8:eastAsia="Microsoft JhengHei">
                 <a:solidFill>
                   <a:srgbClr val="1B2A4A"/>
                 </a:solidFill>
@@ -11438,7 +12252,7 @@
           <a:p>
             <a:pPr algn="l"/>
             <a:r>
-              <a:rPr sz="1100">
+              <a:rPr xmlns:ns9="http://schemas.openxmlformats.org/wordprocessingml/2006/main" sz="1400" ns9:eastAsia="Microsoft JhengHei">
                 <a:solidFill>
                   <a:srgbClr val="3A4A63"/>
                 </a:solidFill>
@@ -11470,22 +12284,101 @@
           <a:noFill/>
         </p:spPr>
         <p:txBody>
-          <a:bodyPr wrap="none">
+          <a:bodyPr wrap="square">
             <a:spAutoFit/>
           </a:bodyPr>
           <a:lstStyle/>
           <a:p>
             <a:pPr algn="r"/>
             <a:r>
+              <a:rPr xmlns:ns10="http://schemas.openxmlformats.org/wordprocessingml/2006/main" sz="1400" ns10:eastAsia="Microsoft JhengHei">
+                <a:solidFill>
+                  <a:srgbClr val="6B7280"/>
+                </a:solidFill>
+                <a:latin typeface="Microsoft JhengHei"/>
+                <a:rFonts ea="Microsoft JhengHei"/>
+              </a:rPr>
+              <a:t>6</a:t>
+            </a:r>
+          </a:p>
+        </p:txBody>
+      </p:sp>
+      <p:sp>
+        <p:nvSpPr>
+          <p:cNvPr id="27" name="TextBox 26"/>
+          <p:cNvSpPr txBox="1"/>
+          <p:nvPr/>
+        </p:nvSpPr>
+        <p:spPr>
+          <a:xfrm>
+            <a:off x="11247120" y="6446520"/>
+            <a:ext cx="731520" cy="274320"/>
+          </a:xfrm>
+          <a:prstGeom prst="rect">
+            <a:avLst/>
+          </a:prstGeom>
+          <a:noFill/>
+        </p:spPr>
+        <p:txBody>
+          <a:bodyPr wrap="square">
+            <a:spAutoFit/>
+          </a:bodyPr>
+          <a:lstStyle/>
+          <a:p>
+            <a:pPr algn="r"/>
+            <a:r>
               <a:rPr sz="900">
                 <a:solidFill>
                   <a:srgbClr val="6B7280"/>
                 </a:solidFill>
                 <a:latin typeface="Microsoft JhengHei"/>
-                <a:rFonts ea="Microsoft JhengHei"/>
+                <a:rFonts a:ea="Microsoft JhengHei"/>
               </a:rPr>
               <a:t>6</a:t>
             </a:r>
+          </a:p>
+        </p:txBody>
+      </p:sp>
+      <p:sp>
+        <p:nvSpPr>
+          <p:cNvPr id="28" name="Rectangle 27"/>
+          <p:cNvSpPr/>
+          <p:nvPr/>
+        </p:nvSpPr>
+        <p:spPr>
+          <a:xfrm>
+            <a:off x="320040" y="1371600"/>
+            <a:ext cx="73152" cy="5029200"/>
+          </a:xfrm>
+          <a:prstGeom prst="rect">
+            <a:avLst/>
+          </a:prstGeom>
+          <a:solidFill>
+            <a:srgbClr val="8B5CF6"/>
+          </a:solidFill>
+          <a:ln>
+            <a:noFill/>
+          </a:ln>
+        </p:spPr>
+        <p:style>
+          <a:lnRef idx="1">
+            <a:schemeClr val="accent1"/>
+          </a:lnRef>
+          <a:fillRef idx="3">
+            <a:schemeClr val="accent1"/>
+          </a:fillRef>
+          <a:effectRef idx="2">
+            <a:schemeClr val="accent1"/>
+          </a:effectRef>
+          <a:fontRef idx="minor">
+            <a:schemeClr val="lt1"/>
+          </a:fontRef>
+        </p:style>
+        <p:txBody>
+          <a:bodyPr rtlCol="0" anchor="ctr" wrap="square"/>
+          <a:lstStyle/>
+          <a:p>
+            <a:pPr algn="ctr"/>
           </a:p>
         </p:txBody>
       </p:sp>
@@ -11539,7 +12432,7 @@
           <a:p>
             <a:pPr algn="l"/>
             <a:r>
-              <a:rPr sz="3000" b="1">
+              <a:rPr xmlns:ns0="http://schemas.openxmlformats.org/wordprocessingml/2006/main" sz="3000" b="1" ns0:eastAsia="Microsoft JhengHei">
                 <a:solidFill>
                   <a:srgbClr val="1B2A4A"/>
                 </a:solidFill>
@@ -11575,7 +12468,7 @@
           <a:p>
             <a:pPr algn="l"/>
             <a:r>
-              <a:rPr sz="1400">
+              <a:rPr xmlns:ns1="http://schemas.openxmlformats.org/wordprocessingml/2006/main" sz="1400" ns1:eastAsia="Microsoft JhengHei">
                 <a:solidFill>
                   <a:srgbClr val="0E7C86"/>
                 </a:solidFill>
@@ -11625,7 +12518,7 @@
           </a:fontRef>
         </p:style>
         <p:txBody>
-          <a:bodyPr rtlCol="0" anchor="ctr"/>
+          <a:bodyPr rtlCol="0" anchor="ctr" wrap="square"/>
           <a:lstStyle/>
           <a:p>
             <a:pPr algn="ctr"/>
@@ -11668,7 +12561,7 @@
           </a:fontRef>
         </p:style>
         <p:txBody>
-          <a:bodyPr rtlCol="0" anchor="ctr"/>
+          <a:bodyPr rtlCol="0" anchor="ctr" wrap="square"/>
           <a:lstStyle/>
           <a:p>
             <a:pPr algn="ctr"/>
@@ -11699,7 +12592,7 @@
           <a:p>
             <a:pPr algn="l"/>
             <a:r>
-              <a:rPr sz="1100">
+              <a:rPr xmlns:ns2="http://schemas.openxmlformats.org/wordprocessingml/2006/main" sz="1400" ns2:eastAsia="Microsoft JhengHei">
                 <a:solidFill>
                   <a:srgbClr val="3A4A63"/>
                 </a:solidFill>
@@ -11750,7 +12643,7 @@
           </a:fontRef>
         </p:style>
         <p:txBody>
-          <a:bodyPr rtlCol="0" anchor="ctr"/>
+          <a:bodyPr rtlCol="0" anchor="ctr" wrap="square"/>
           <a:lstStyle/>
           <a:p>
             <a:pPr algn="ctr"/>
@@ -11793,7 +12686,7 @@
           </a:fontRef>
         </p:style>
         <p:txBody>
-          <a:bodyPr rtlCol="0" anchor="ctr"/>
+          <a:bodyPr rtlCol="0" anchor="ctr" wrap="square"/>
           <a:lstStyle/>
           <a:p>
             <a:pPr algn="ctr"/>
@@ -11824,7 +12717,7 @@
           <a:p>
             <a:pPr algn="l"/>
             <a:r>
-              <a:rPr sz="1100">
+              <a:rPr xmlns:ns3="http://schemas.openxmlformats.org/wordprocessingml/2006/main" sz="1400" ns3:eastAsia="Microsoft JhengHei">
                 <a:solidFill>
                   <a:srgbClr val="3A4A63"/>
                 </a:solidFill>
@@ -11875,7 +12768,7 @@
           </a:fontRef>
         </p:style>
         <p:txBody>
-          <a:bodyPr rtlCol="0" anchor="ctr"/>
+          <a:bodyPr rtlCol="0" anchor="ctr" wrap="square"/>
           <a:lstStyle/>
           <a:p>
             <a:pPr algn="ctr"/>
@@ -11918,7 +12811,7 @@
           </a:fontRef>
         </p:style>
         <p:txBody>
-          <a:bodyPr rtlCol="0" anchor="ctr"/>
+          <a:bodyPr rtlCol="0" anchor="ctr" wrap="square"/>
           <a:lstStyle/>
           <a:p>
             <a:pPr algn="ctr"/>
@@ -11949,7 +12842,7 @@
           <a:p>
             <a:pPr algn="l"/>
             <a:r>
-              <a:rPr sz="1100">
+              <a:rPr xmlns:ns4="http://schemas.openxmlformats.org/wordprocessingml/2006/main" sz="1400" ns4:eastAsia="Microsoft JhengHei">
                 <a:solidFill>
                   <a:srgbClr val="3A4A63"/>
                 </a:solidFill>
@@ -12000,7 +12893,7 @@
           </a:fontRef>
         </p:style>
         <p:txBody>
-          <a:bodyPr rtlCol="0" anchor="ctr"/>
+          <a:bodyPr rtlCol="0" anchor="ctr" wrap="square"/>
           <a:lstStyle/>
           <a:p>
             <a:pPr algn="ctr"/>
@@ -12043,7 +12936,7 @@
           </a:fontRef>
         </p:style>
         <p:txBody>
-          <a:bodyPr rtlCol="0" anchor="ctr"/>
+          <a:bodyPr rtlCol="0" anchor="ctr" wrap="square"/>
           <a:lstStyle/>
           <a:p>
             <a:pPr algn="ctr"/>
@@ -12074,7 +12967,7 @@
           <a:p>
             <a:pPr algn="l"/>
             <a:r>
-              <a:rPr sz="1400" b="1">
+              <a:rPr xmlns:ns5="http://schemas.openxmlformats.org/wordprocessingml/2006/main" sz="1400" b="1" ns5:eastAsia="Microsoft JhengHei">
                 <a:solidFill>
                   <a:srgbClr val="1B2A4A"/>
                 </a:solidFill>
@@ -12110,7 +13003,7 @@
           <a:p>
             <a:pPr algn="l"/>
             <a:r>
-              <a:rPr sz="1100">
+              <a:rPr xmlns:ns6="http://schemas.openxmlformats.org/wordprocessingml/2006/main" sz="1400" ns6:eastAsia="Microsoft JhengHei">
                 <a:solidFill>
                   <a:srgbClr val="3A4A63"/>
                 </a:solidFill>
@@ -12163,7 +13056,7 @@
           </a:fontRef>
         </p:style>
         <p:txBody>
-          <a:bodyPr rtlCol="0" anchor="ctr"/>
+          <a:bodyPr rtlCol="0" anchor="ctr" wrap="square"/>
           <a:lstStyle/>
           <a:p>
             <a:pPr algn="ctr"/>
@@ -12194,7 +13087,7 @@
           <a:p>
             <a:pPr algn="ctr"/>
             <a:r>
-              <a:rPr sz="1150" b="1">
+              <a:rPr xmlns:ns7="http://schemas.openxmlformats.org/wordprocessingml/2006/main" sz="1400" b="1" ns7:eastAsia="Microsoft JhengHei">
                 <a:solidFill>
                   <a:srgbClr val="0E7C86"/>
                 </a:solidFill>
@@ -12223,21 +13116,155 @@
           <a:noFill/>
         </p:spPr>
         <p:txBody>
-          <a:bodyPr wrap="none">
+          <a:bodyPr wrap="square">
             <a:spAutoFit/>
           </a:bodyPr>
           <a:lstStyle/>
           <a:p>
             <a:pPr algn="r"/>
             <a:r>
+              <a:rPr xmlns:ns8="http://schemas.openxmlformats.org/wordprocessingml/2006/main" sz="1400" ns8:eastAsia="Microsoft JhengHei">
+                <a:solidFill>
+                  <a:srgbClr val="6B7280"/>
+                </a:solidFill>
+                <a:latin typeface="Microsoft JhengHei"/>
+                <a:rFonts ea="Microsoft JhengHei"/>
+              </a:rPr>
+              <a:t>7</a:t>
+            </a:r>
+          </a:p>
+        </p:txBody>
+      </p:sp>
+      <p:sp>
+        <p:nvSpPr>
+          <p:cNvPr id="20" name="TextBox 19"/>
+          <p:cNvSpPr txBox="1"/>
+          <p:nvPr/>
+        </p:nvSpPr>
+        <p:spPr>
+          <a:xfrm>
+            <a:off x="11247120" y="6446520"/>
+            <a:ext cx="731520" cy="274320"/>
+          </a:xfrm>
+          <a:prstGeom prst="rect">
+            <a:avLst/>
+          </a:prstGeom>
+          <a:noFill/>
+        </p:spPr>
+        <p:txBody>
+          <a:bodyPr wrap="square">
+            <a:spAutoFit/>
+          </a:bodyPr>
+          <a:lstStyle/>
+          <a:p>
+            <a:pPr algn="r"/>
+            <a:r>
               <a:rPr sz="900">
                 <a:solidFill>
                   <a:srgbClr val="6B7280"/>
                 </a:solidFill>
                 <a:latin typeface="Microsoft JhengHei"/>
-                <a:rFonts ea="Microsoft JhengHei"/>
+                <a:rFonts a:ea="Microsoft JhengHei"/>
               </a:rPr>
               <a:t>7</a:t>
+            </a:r>
+          </a:p>
+        </p:txBody>
+      </p:sp>
+      <p:sp>
+        <p:nvSpPr>
+          <p:cNvPr id="21" name="Rectangle 20"/>
+          <p:cNvSpPr/>
+          <p:nvPr/>
+        </p:nvSpPr>
+        <p:spPr>
+          <a:xfrm>
+            <a:off x="320040" y="1371600"/>
+            <a:ext cx="73152" cy="5029200"/>
+          </a:xfrm>
+          <a:prstGeom prst="rect">
+            <a:avLst/>
+          </a:prstGeom>
+          <a:solidFill>
+            <a:srgbClr val="10B981"/>
+          </a:solidFill>
+          <a:ln>
+            <a:noFill/>
+          </a:ln>
+        </p:spPr>
+        <p:style>
+          <a:lnRef idx="1">
+            <a:schemeClr val="accent1"/>
+          </a:lnRef>
+          <a:fillRef idx="3">
+            <a:schemeClr val="accent1"/>
+          </a:fillRef>
+          <a:effectRef idx="2">
+            <a:schemeClr val="accent1"/>
+          </a:effectRef>
+          <a:fontRef idx="minor">
+            <a:schemeClr val="lt1"/>
+          </a:fontRef>
+        </p:style>
+        <p:txBody>
+          <a:bodyPr rtlCol="0" anchor="ctr" wrap="square"/>
+          <a:lstStyle/>
+          <a:p>
+            <a:pPr algn="ctr"/>
+          </a:p>
+        </p:txBody>
+      </p:sp>
+      <p:sp>
+        <p:nvSpPr>
+          <p:cNvPr id="22" name="Rounded Rectangle 21"/>
+          <p:cNvSpPr/>
+          <p:nvPr/>
+        </p:nvSpPr>
+        <p:spPr>
+          <a:xfrm>
+            <a:off x="457200" y="5943600"/>
+            <a:ext cx="11247120" cy="502920"/>
+          </a:xfrm>
+          <a:prstGeom prst="roundRect">
+            <a:avLst/>
+          </a:prstGeom>
+          <a:solidFill>
+            <a:srgbClr val="E7F1F2"/>
+          </a:solidFill>
+          <a:ln w="9525">
+            <a:solidFill>
+              <a:srgbClr val="D8DEE7"/>
+            </a:solidFill>
+          </a:ln>
+        </p:spPr>
+        <p:style>
+          <a:lnRef idx="1">
+            <a:schemeClr val="accent1"/>
+          </a:lnRef>
+          <a:fillRef idx="3">
+            <a:schemeClr val="accent1"/>
+          </a:fillRef>
+          <a:effectRef idx="2">
+            <a:schemeClr val="accent1"/>
+          </a:effectRef>
+          <a:fontRef idx="minor">
+            <a:schemeClr val="lt1"/>
+          </a:fontRef>
+        </p:style>
+        <p:txBody>
+          <a:bodyPr rtlCol="0" anchor="ctr" wrap="square"/>
+          <a:lstStyle/>
+          <a:p>
+            <a:pPr algn="ctr"/>
+            <a:r>
+              <a:rPr xmlns:ns9="http://schemas.openxmlformats.org/wordprocessingml/2006/main" sz="1400" b="1" ns9:eastAsia="Microsoft JhengHei">
+                <a:solidFill>
+                  <a:srgbClr val="0E7C86"/>
+                </a:solidFill>
+                <a:latin typeface="Microsoft JhengHei"/>
+                <a:rFonts a:ea="Microsoft JhengHei"/>
+              </a:rPr>
+              <a:t>實測數據：節省 60%+ Token 消耗 | 任務完成率提升 4 倍以上 | 壓縮閾值 83.5% | 系統緩衝區 ~33K tokens</a:t>
             </a:r>
           </a:p>
         </p:txBody>
@@ -12292,7 +13319,7 @@
           <a:p>
             <a:pPr algn="l"/>
             <a:r>
-              <a:rPr sz="3000" b="1">
+              <a:rPr xmlns:ns0="http://schemas.openxmlformats.org/wordprocessingml/2006/main" sz="3000" b="1" ns0:eastAsia="Microsoft JhengHei">
                 <a:solidFill>
                   <a:srgbClr val="1B2A4A"/>
                 </a:solidFill>
@@ -12328,7 +13355,7 @@
           <a:p>
             <a:pPr algn="l"/>
             <a:r>
-              <a:rPr sz="1400">
+              <a:rPr xmlns:ns1="http://schemas.openxmlformats.org/wordprocessingml/2006/main" sz="1400" ns1:eastAsia="Microsoft JhengHei">
                 <a:solidFill>
                   <a:srgbClr val="0E7C86"/>
                 </a:solidFill>
@@ -12378,7 +13405,7 @@
           </a:fontRef>
         </p:style>
         <p:txBody>
-          <a:bodyPr rtlCol="0" anchor="ctr"/>
+          <a:bodyPr rtlCol="0" anchor="ctr" wrap="square"/>
           <a:lstStyle/>
           <a:p>
             <a:pPr algn="ctr"/>
@@ -12421,7 +13448,7 @@
           </a:fontRef>
         </p:style>
         <p:txBody>
-          <a:bodyPr rtlCol="0" anchor="ctr"/>
+          <a:bodyPr rtlCol="0" anchor="ctr" wrap="square"/>
           <a:lstStyle/>
           <a:p>
             <a:pPr algn="ctr"/>
@@ -12452,7 +13479,7 @@
           <a:p>
             <a:pPr algn="l"/>
             <a:r>
-              <a:rPr sz="1200" b="1">
+              <a:rPr xmlns:ns2="http://schemas.openxmlformats.org/wordprocessingml/2006/main" sz="1400" b="1" ns2:eastAsia="Microsoft JhengHei">
                 <a:solidFill>
                   <a:srgbClr val="1B2A4A"/>
                 </a:solidFill>
@@ -12502,7 +13529,7 @@
           </a:fontRef>
         </p:style>
         <p:txBody>
-          <a:bodyPr rtlCol="0" anchor="ctr"/>
+          <a:bodyPr rtlCol="0" anchor="ctr" wrap="square"/>
           <a:lstStyle/>
           <a:p>
             <a:pPr algn="ctr"/>
@@ -12545,7 +13572,7 @@
           </a:fontRef>
         </p:style>
         <p:txBody>
-          <a:bodyPr rtlCol="0" anchor="ctr"/>
+          <a:bodyPr rtlCol="0" anchor="ctr" wrap="square"/>
           <a:lstStyle/>
           <a:p>
             <a:pPr algn="ctr"/>
@@ -12576,7 +13603,7 @@
           <a:p>
             <a:pPr algn="l"/>
             <a:r>
-              <a:rPr sz="1200" b="1">
+              <a:rPr xmlns:ns3="http://schemas.openxmlformats.org/wordprocessingml/2006/main" sz="1400" b="1" ns3:eastAsia="Microsoft JhengHei">
                 <a:solidFill>
                   <a:srgbClr val="1B2A4A"/>
                 </a:solidFill>
@@ -12626,7 +13653,7 @@
           </a:fontRef>
         </p:style>
         <p:txBody>
-          <a:bodyPr rtlCol="0" anchor="ctr"/>
+          <a:bodyPr rtlCol="0" anchor="ctr" wrap="square"/>
           <a:lstStyle/>
           <a:p>
             <a:pPr algn="ctr"/>
@@ -12669,7 +13696,7 @@
           </a:fontRef>
         </p:style>
         <p:txBody>
-          <a:bodyPr rtlCol="0" anchor="ctr"/>
+          <a:bodyPr rtlCol="0" anchor="ctr" wrap="square"/>
           <a:lstStyle/>
           <a:p>
             <a:pPr algn="ctr"/>
@@ -12700,7 +13727,7 @@
           <a:p>
             <a:pPr algn="l"/>
             <a:r>
-              <a:rPr sz="1200" b="1">
+              <a:rPr xmlns:ns4="http://schemas.openxmlformats.org/wordprocessingml/2006/main" sz="1400" b="1" ns4:eastAsia="Microsoft JhengHei">
                 <a:solidFill>
                   <a:srgbClr val="1B2A4A"/>
                 </a:solidFill>
@@ -12750,7 +13777,7 @@
           </a:fontRef>
         </p:style>
         <p:txBody>
-          <a:bodyPr rtlCol="0" anchor="ctr"/>
+          <a:bodyPr rtlCol="0" anchor="ctr" wrap="square"/>
           <a:lstStyle/>
           <a:p>
             <a:pPr algn="ctr"/>
@@ -12793,7 +13820,7 @@
           </a:fontRef>
         </p:style>
         <p:txBody>
-          <a:bodyPr rtlCol="0" anchor="ctr"/>
+          <a:bodyPr rtlCol="0" anchor="ctr" wrap="square"/>
           <a:lstStyle/>
           <a:p>
             <a:pPr algn="ctr"/>
@@ -12824,7 +13851,7 @@
           <a:p>
             <a:pPr algn="l"/>
             <a:r>
-              <a:rPr sz="1200" b="1">
+              <a:rPr xmlns:ns5="http://schemas.openxmlformats.org/wordprocessingml/2006/main" sz="1400" b="1" ns5:eastAsia="Microsoft JhengHei">
                 <a:solidFill>
                   <a:srgbClr val="1B2A4A"/>
                 </a:solidFill>
@@ -12874,7 +13901,7 @@
           </a:fontRef>
         </p:style>
         <p:txBody>
-          <a:bodyPr rtlCol="0" anchor="ctr"/>
+          <a:bodyPr rtlCol="0" anchor="ctr" wrap="square"/>
           <a:lstStyle/>
           <a:p>
             <a:pPr algn="ctr"/>
@@ -12917,7 +13944,7 @@
           </a:fontRef>
         </p:style>
         <p:txBody>
-          <a:bodyPr rtlCol="0" anchor="ctr"/>
+          <a:bodyPr rtlCol="0" anchor="ctr" wrap="square"/>
           <a:lstStyle/>
           <a:p>
             <a:pPr algn="ctr"/>
@@ -12948,7 +13975,7 @@
           <a:p>
             <a:pPr algn="l"/>
             <a:r>
-              <a:rPr sz="1200" b="1">
+              <a:rPr xmlns:ns6="http://schemas.openxmlformats.org/wordprocessingml/2006/main" sz="1400" b="1" ns6:eastAsia="Microsoft JhengHei">
                 <a:solidFill>
                   <a:srgbClr val="1B2A4A"/>
                 </a:solidFill>
@@ -12998,7 +14025,7 @@
           </a:fontRef>
         </p:style>
         <p:txBody>
-          <a:bodyPr rtlCol="0" anchor="ctr"/>
+          <a:bodyPr rtlCol="0" anchor="ctr" wrap="square"/>
           <a:lstStyle/>
           <a:p>
             <a:pPr algn="ctr"/>
@@ -13041,7 +14068,7 @@
           </a:fontRef>
         </p:style>
         <p:txBody>
-          <a:bodyPr rtlCol="0" anchor="ctr"/>
+          <a:bodyPr rtlCol="0" anchor="ctr" wrap="square"/>
           <a:lstStyle/>
           <a:p>
             <a:pPr algn="ctr"/>
@@ -13072,7 +14099,7 @@
           <a:p>
             <a:pPr algn="l"/>
             <a:r>
-              <a:rPr sz="1400" b="1">
+              <a:rPr xmlns:ns7="http://schemas.openxmlformats.org/wordprocessingml/2006/main" sz="1400" b="1" ns7:eastAsia="Microsoft JhengHei">
                 <a:solidFill>
                   <a:srgbClr val="1B2A4A"/>
                 </a:solidFill>
@@ -13108,7 +14135,7 @@
           <a:p>
             <a:pPr algn="l"/>
             <a:r>
-              <a:rPr sz="1100">
+              <a:rPr xmlns:ns8="http://schemas.openxmlformats.org/wordprocessingml/2006/main" sz="1400" ns8:eastAsia="Microsoft JhengHei">
                 <a:solidFill>
                   <a:srgbClr val="3A4A63"/>
                 </a:solidFill>
@@ -13141,22 +14168,101 @@
           <a:noFill/>
         </p:spPr>
         <p:txBody>
-          <a:bodyPr wrap="none">
+          <a:bodyPr wrap="square">
             <a:spAutoFit/>
           </a:bodyPr>
           <a:lstStyle/>
           <a:p>
             <a:pPr algn="r"/>
             <a:r>
+              <a:rPr xmlns:ns9="http://schemas.openxmlformats.org/wordprocessingml/2006/main" sz="1400" ns9:eastAsia="Microsoft JhengHei">
+                <a:solidFill>
+                  <a:srgbClr val="6B7280"/>
+                </a:solidFill>
+                <a:latin typeface="Microsoft JhengHei"/>
+                <a:rFonts ea="Microsoft JhengHei"/>
+              </a:rPr>
+              <a:t>8</a:t>
+            </a:r>
+          </a:p>
+        </p:txBody>
+      </p:sp>
+      <p:sp>
+        <p:nvSpPr>
+          <p:cNvPr id="24" name="TextBox 23"/>
+          <p:cNvSpPr txBox="1"/>
+          <p:nvPr/>
+        </p:nvSpPr>
+        <p:spPr>
+          <a:xfrm>
+            <a:off x="11247120" y="6446520"/>
+            <a:ext cx="731520" cy="274320"/>
+          </a:xfrm>
+          <a:prstGeom prst="rect">
+            <a:avLst/>
+          </a:prstGeom>
+          <a:noFill/>
+        </p:spPr>
+        <p:txBody>
+          <a:bodyPr wrap="square">
+            <a:spAutoFit/>
+          </a:bodyPr>
+          <a:lstStyle/>
+          <a:p>
+            <a:pPr algn="r"/>
+            <a:r>
               <a:rPr sz="900">
                 <a:solidFill>
                   <a:srgbClr val="6B7280"/>
                 </a:solidFill>
                 <a:latin typeface="Microsoft JhengHei"/>
-                <a:rFonts ea="Microsoft JhengHei"/>
+                <a:rFonts a:ea="Microsoft JhengHei"/>
               </a:rPr>
               <a:t>8</a:t>
             </a:r>
+          </a:p>
+        </p:txBody>
+      </p:sp>
+      <p:sp>
+        <p:nvSpPr>
+          <p:cNvPr id="25" name="Rectangle 24"/>
+          <p:cNvSpPr/>
+          <p:nvPr/>
+        </p:nvSpPr>
+        <p:spPr>
+          <a:xfrm>
+            <a:off x="320040" y="1371600"/>
+            <a:ext cx="73152" cy="5029200"/>
+          </a:xfrm>
+          <a:prstGeom prst="rect">
+            <a:avLst/>
+          </a:prstGeom>
+          <a:solidFill>
+            <a:srgbClr val="E74C3C"/>
+          </a:solidFill>
+          <a:ln>
+            <a:noFill/>
+          </a:ln>
+        </p:spPr>
+        <p:style>
+          <a:lnRef idx="1">
+            <a:schemeClr val="accent1"/>
+          </a:lnRef>
+          <a:fillRef idx="3">
+            <a:schemeClr val="accent1"/>
+          </a:fillRef>
+          <a:effectRef idx="2">
+            <a:schemeClr val="accent1"/>
+          </a:effectRef>
+          <a:fontRef idx="minor">
+            <a:schemeClr val="lt1"/>
+          </a:fontRef>
+        </p:style>
+        <p:txBody>
+          <a:bodyPr rtlCol="0" anchor="ctr" wrap="square"/>
+          <a:lstStyle/>
+          <a:p>
+            <a:pPr algn="ctr"/>
           </a:p>
         </p:txBody>
       </p:sp>
@@ -13210,7 +14316,7 @@
           <a:p>
             <a:pPr algn="l"/>
             <a:r>
-              <a:rPr sz="3000" b="1">
+              <a:rPr xmlns:ns0="http://schemas.openxmlformats.org/wordprocessingml/2006/main" sz="3000" b="1" ns0:eastAsia="Microsoft JhengHei">
                 <a:solidFill>
                   <a:srgbClr val="1B2A4A"/>
                 </a:solidFill>
@@ -13246,7 +14352,7 @@
           <a:p>
             <a:pPr algn="l"/>
             <a:r>
-              <a:rPr sz="1400">
+              <a:rPr xmlns:ns1="http://schemas.openxmlformats.org/wordprocessingml/2006/main" sz="1400" ns1:eastAsia="Microsoft JhengHei">
                 <a:solidFill>
                   <a:srgbClr val="0E7C86"/>
                 </a:solidFill>
@@ -13296,7 +14402,7 @@
           </a:fontRef>
         </p:style>
         <p:txBody>
-          <a:bodyPr rtlCol="0" anchor="ctr"/>
+          <a:bodyPr rtlCol="0" anchor="ctr" wrap="square"/>
           <a:lstStyle/>
           <a:p>
             <a:pPr algn="ctr">
@@ -13308,6 +14414,13 @@
               </a:defRPr>
             </a:pPr>
             <a:r>
+              <a:rPr xmlns:ns2="http://schemas.openxmlformats.org/wordprocessingml/2006/main" sz="1800" ns2:eastAsia="Microsoft JhengHei">
+                <a:solidFill>
+                  <a:srgbClr val="FFFFFF"/>
+                </a:solidFill>
+                <a:latin typeface="Microsoft JhengHei"/>
+                <a:rFonts a:ea="Microsoft JhengHei"/>
+              </a:rPr>
               <a:t>Think</a:t>
             </a:r>
           </a:p>
@@ -13351,7 +14464,7 @@
           </a:fontRef>
         </p:style>
         <p:txBody>
-          <a:bodyPr rtlCol="0" anchor="ctr"/>
+          <a:bodyPr rtlCol="0" anchor="ctr" wrap="square"/>
           <a:lstStyle/>
           <a:p>
             <a:pPr algn="ctr">
@@ -13363,6 +14476,13 @@
               </a:defRPr>
             </a:pPr>
             <a:r>
+              <a:rPr xmlns:ns3="http://schemas.openxmlformats.org/wordprocessingml/2006/main" sz="1800" ns3:eastAsia="Microsoft JhengHei">
+                <a:solidFill>
+                  <a:srgbClr val="FFFFFF"/>
+                </a:solidFill>
+                <a:latin typeface="Microsoft JhengHei"/>
+                <a:rFonts a:ea="Microsoft JhengHei"/>
+              </a:rPr>
               <a:t>Act</a:t>
             </a:r>
           </a:p>
@@ -13406,7 +14526,7 @@
           </a:fontRef>
         </p:style>
         <p:txBody>
-          <a:bodyPr rtlCol="0" anchor="ctr"/>
+          <a:bodyPr rtlCol="0" anchor="ctr" wrap="square"/>
           <a:lstStyle/>
           <a:p>
             <a:pPr algn="ctr">
@@ -13418,6 +14538,13 @@
               </a:defRPr>
             </a:pPr>
             <a:r>
+              <a:rPr xmlns:ns4="http://schemas.openxmlformats.org/wordprocessingml/2006/main" sz="1800" ns4:eastAsia="Microsoft JhengHei">
+                <a:solidFill>
+                  <a:srgbClr val="FFFFFF"/>
+                </a:solidFill>
+                <a:latin typeface="Microsoft JhengHei"/>
+                <a:rFonts a:ea="Microsoft JhengHei"/>
+              </a:rPr>
               <a:t>Observe</a:t>
             </a:r>
           </a:p>
@@ -13461,7 +14588,7 @@
           </a:fontRef>
         </p:style>
         <p:txBody>
-          <a:bodyPr rtlCol="0" anchor="ctr"/>
+          <a:bodyPr rtlCol="0" anchor="ctr" wrap="square"/>
           <a:lstStyle/>
           <a:p>
             <a:pPr algn="ctr">
@@ -13473,6 +14600,13 @@
               </a:defRPr>
             </a:pPr>
             <a:r>
+              <a:rPr xmlns:ns5="http://schemas.openxmlformats.org/wordprocessingml/2006/main" sz="1800" ns5:eastAsia="Microsoft JhengHei">
+                <a:solidFill>
+                  <a:srgbClr val="FFFFFF"/>
+                </a:solidFill>
+                <a:latin typeface="Microsoft JhengHei"/>
+                <a:rFonts a:ea="Microsoft JhengHei"/>
+              </a:rPr>
               <a:t>Repeat</a:t>
             </a:r>
           </a:p>
@@ -13516,7 +14650,7 @@
           </a:fontRef>
         </p:style>
         <p:txBody>
-          <a:bodyPr rtlCol="0" anchor="ctr"/>
+          <a:bodyPr rtlCol="0" anchor="ctr" wrap="square"/>
           <a:lstStyle/>
           <a:p>
             <a:pPr algn="ctr"/>
@@ -13559,7 +14693,7 @@
           </a:fontRef>
         </p:style>
         <p:txBody>
-          <a:bodyPr rtlCol="0" anchor="ctr"/>
+          <a:bodyPr rtlCol="0" anchor="ctr" wrap="square"/>
           <a:lstStyle/>
           <a:p>
             <a:pPr algn="ctr"/>
@@ -13590,7 +14724,7 @@
           <a:p>
             <a:pPr algn="l"/>
             <a:r>
-              <a:rPr sz="1100">
+              <a:rPr xmlns:ns6="http://schemas.openxmlformats.org/wordprocessingml/2006/main" sz="1400" ns6:eastAsia="Microsoft JhengHei">
                 <a:solidFill>
                   <a:srgbClr val="3A4A63"/>
                 </a:solidFill>
@@ -13642,7 +14776,7 @@
           </a:fontRef>
         </p:style>
         <p:txBody>
-          <a:bodyPr rtlCol="0" anchor="ctr"/>
+          <a:bodyPr rtlCol="0" anchor="ctr" wrap="square"/>
           <a:lstStyle/>
           <a:p>
             <a:pPr algn="ctr"/>
@@ -13685,7 +14819,7 @@
           </a:fontRef>
         </p:style>
         <p:txBody>
-          <a:bodyPr rtlCol="0" anchor="ctr"/>
+          <a:bodyPr rtlCol="0" anchor="ctr" wrap="square"/>
           <a:lstStyle/>
           <a:p>
             <a:pPr algn="ctr"/>
@@ -13716,7 +14850,7 @@
           <a:p>
             <a:pPr algn="l"/>
             <a:r>
-              <a:rPr sz="1100">
+              <a:rPr xmlns:ns7="http://schemas.openxmlformats.org/wordprocessingml/2006/main" sz="1400" ns7:eastAsia="Microsoft JhengHei">
                 <a:solidFill>
                   <a:srgbClr val="3A4A63"/>
                 </a:solidFill>
@@ -13749,21 +14883,155 @@
           <a:noFill/>
         </p:spPr>
         <p:txBody>
-          <a:bodyPr wrap="none">
+          <a:bodyPr wrap="square">
             <a:spAutoFit/>
           </a:bodyPr>
           <a:lstStyle/>
           <a:p>
             <a:pPr algn="r"/>
             <a:r>
+              <a:rPr xmlns:ns8="http://schemas.openxmlformats.org/wordprocessingml/2006/main" sz="1400" ns8:eastAsia="Microsoft JhengHei">
+                <a:solidFill>
+                  <a:srgbClr val="6B7280"/>
+                </a:solidFill>
+                <a:latin typeface="Microsoft JhengHei"/>
+                <a:rFonts ea="Microsoft JhengHei"/>
+              </a:rPr>
+              <a:t>9</a:t>
+            </a:r>
+          </a:p>
+        </p:txBody>
+      </p:sp>
+      <p:sp>
+        <p:nvSpPr>
+          <p:cNvPr id="15" name="TextBox 14"/>
+          <p:cNvSpPr txBox="1"/>
+          <p:nvPr/>
+        </p:nvSpPr>
+        <p:spPr>
+          <a:xfrm>
+            <a:off x="11247120" y="6446520"/>
+            <a:ext cx="731520" cy="274320"/>
+          </a:xfrm>
+          <a:prstGeom prst="rect">
+            <a:avLst/>
+          </a:prstGeom>
+          <a:noFill/>
+        </p:spPr>
+        <p:txBody>
+          <a:bodyPr wrap="square">
+            <a:spAutoFit/>
+          </a:bodyPr>
+          <a:lstStyle/>
+          <a:p>
+            <a:pPr algn="r"/>
+            <a:r>
               <a:rPr sz="900">
                 <a:solidFill>
                   <a:srgbClr val="6B7280"/>
                 </a:solidFill>
                 <a:latin typeface="Microsoft JhengHei"/>
-                <a:rFonts ea="Microsoft JhengHei"/>
+                <a:rFonts a:ea="Microsoft JhengHei"/>
               </a:rPr>
               <a:t>9</a:t>
+            </a:r>
+          </a:p>
+        </p:txBody>
+      </p:sp>
+      <p:sp>
+        <p:nvSpPr>
+          <p:cNvPr id="16" name="Rectangle 15"/>
+          <p:cNvSpPr/>
+          <p:nvPr/>
+        </p:nvSpPr>
+        <p:spPr>
+          <a:xfrm>
+            <a:off x="320040" y="1371600"/>
+            <a:ext cx="73152" cy="5029200"/>
+          </a:xfrm>
+          <a:prstGeom prst="rect">
+            <a:avLst/>
+          </a:prstGeom>
+          <a:solidFill>
+            <a:srgbClr val="F5A623"/>
+          </a:solidFill>
+          <a:ln>
+            <a:noFill/>
+          </a:ln>
+        </p:spPr>
+        <p:style>
+          <a:lnRef idx="1">
+            <a:schemeClr val="accent1"/>
+          </a:lnRef>
+          <a:fillRef idx="3">
+            <a:schemeClr val="accent1"/>
+          </a:fillRef>
+          <a:effectRef idx="2">
+            <a:schemeClr val="accent1"/>
+          </a:effectRef>
+          <a:fontRef idx="minor">
+            <a:schemeClr val="lt1"/>
+          </a:fontRef>
+        </p:style>
+        <p:txBody>
+          <a:bodyPr rtlCol="0" anchor="ctr" wrap="square"/>
+          <a:lstStyle/>
+          <a:p>
+            <a:pPr algn="ctr"/>
+          </a:p>
+        </p:txBody>
+      </p:sp>
+      <p:sp>
+        <p:nvSpPr>
+          <p:cNvPr id="17" name="Rounded Rectangle 16"/>
+          <p:cNvSpPr/>
+          <p:nvPr/>
+        </p:nvSpPr>
+        <p:spPr>
+          <a:xfrm>
+            <a:off x="457200" y="5943600"/>
+            <a:ext cx="11247120" cy="502920"/>
+          </a:xfrm>
+          <a:prstGeom prst="roundRect">
+            <a:avLst/>
+          </a:prstGeom>
+          <a:solidFill>
+            <a:srgbClr val="E7F1F2"/>
+          </a:solidFill>
+          <a:ln w="9525">
+            <a:solidFill>
+              <a:srgbClr val="D8DEE7"/>
+            </a:solidFill>
+          </a:ln>
+        </p:spPr>
+        <p:style>
+          <a:lnRef idx="1">
+            <a:schemeClr val="accent1"/>
+          </a:lnRef>
+          <a:fillRef idx="3">
+            <a:schemeClr val="accent1"/>
+          </a:fillRef>
+          <a:effectRef idx="2">
+            <a:schemeClr val="accent1"/>
+          </a:effectRef>
+          <a:fontRef idx="minor">
+            <a:schemeClr val="lt1"/>
+          </a:fontRef>
+        </p:style>
+        <p:txBody>
+          <a:bodyPr rtlCol="0" anchor="ctr" wrap="square"/>
+          <a:lstStyle/>
+          <a:p>
+            <a:pPr algn="ctr"/>
+            <a:r>
+              <a:rPr xmlns:ns9="http://schemas.openxmlformats.org/wordprocessingml/2006/main" sz="1400" b="1" ns9:eastAsia="Microsoft JhengHei">
+                <a:solidFill>
+                  <a:srgbClr val="0E7C86"/>
+                </a:solidFill>
+                <a:latin typeface="Microsoft JhengHei"/>
+                <a:rFonts a:ea="Microsoft JhengHei"/>
+              </a:rPr>
+              <a:t>設計哲學：「將智能全部交給大模型，將確定性留給框架」— 腳手架應隨大模型能力提升而變薄</a:t>
             </a:r>
           </a:p>
         </p:txBody>

</xml_diff>